<commit_message>
prezentacja trzeba uwzaac by nie za dluuuuuuga
</commit_message>
<xml_diff>
--- a/Model Axelroda prezentacja.pptx
+++ b/Model Axelroda prezentacja.pptx
@@ -6,14 +6,16 @@
   </p:sldMasterIdLst>
   <p:sldIdLst>
     <p:sldId id="256" r:id="rId2"/>
-    <p:sldId id="257" r:id="rId3"/>
-    <p:sldId id="258" r:id="rId4"/>
-    <p:sldId id="260" r:id="rId5"/>
-    <p:sldId id="261" r:id="rId6"/>
-    <p:sldId id="262" r:id="rId7"/>
-    <p:sldId id="259" r:id="rId8"/>
-    <p:sldId id="263" r:id="rId9"/>
-    <p:sldId id="264" r:id="rId10"/>
+    <p:sldId id="258" r:id="rId3"/>
+    <p:sldId id="260" r:id="rId4"/>
+    <p:sldId id="261" r:id="rId5"/>
+    <p:sldId id="262" r:id="rId6"/>
+    <p:sldId id="259" r:id="rId7"/>
+    <p:sldId id="263" r:id="rId8"/>
+    <p:sldId id="265" r:id="rId9"/>
+    <p:sldId id="266" r:id="rId10"/>
+    <p:sldId id="267" r:id="rId11"/>
+    <p:sldId id="264" r:id="rId12"/>
   </p:sldIdLst>
   <p:sldSz cx="12192000" cy="6858000"/>
   <p:notesSz cx="6858000" cy="9144000"/>
@@ -112,6 +114,11 @@
       </a:defRPr>
     </a:lvl9pPr>
   </p:defaultTextStyle>
+  <p:extLst>
+    <p:ext uri="{EFAFB233-063F-42B5-8137-9DF3F51BA10A}">
+      <p15:sldGuideLst xmlns:p15="http://schemas.microsoft.com/office/powerpoint/2012/main"/>
+    </p:ext>
+  </p:extLst>
 </p:presentation>
 </file>
 
@@ -264,7 +271,7 @@
           <a:p>
             <a:fld id="{230516DF-AA08-42DB-AE84-024A6CB5A4E7}" type="datetimeFigureOut">
               <a:rPr lang="en-US" smtClean="0"/>
-              <a:t>19-Jun-26</a:t>
+              <a:t>23-Jun-26</a:t>
             </a:fld>
             <a:endParaRPr lang="en-US"/>
           </a:p>
@@ -464,7 +471,7 @@
           <a:p>
             <a:fld id="{230516DF-AA08-42DB-AE84-024A6CB5A4E7}" type="datetimeFigureOut">
               <a:rPr lang="en-US" smtClean="0"/>
-              <a:t>19-Jun-26</a:t>
+              <a:t>23-Jun-26</a:t>
             </a:fld>
             <a:endParaRPr lang="en-US"/>
           </a:p>
@@ -674,7 +681,7 @@
           <a:p>
             <a:fld id="{230516DF-AA08-42DB-AE84-024A6CB5A4E7}" type="datetimeFigureOut">
               <a:rPr lang="en-US" smtClean="0"/>
-              <a:t>19-Jun-26</a:t>
+              <a:t>23-Jun-26</a:t>
             </a:fld>
             <a:endParaRPr lang="en-US"/>
           </a:p>
@@ -874,7 +881,7 @@
           <a:p>
             <a:fld id="{230516DF-AA08-42DB-AE84-024A6CB5A4E7}" type="datetimeFigureOut">
               <a:rPr lang="en-US" smtClean="0"/>
-              <a:t>19-Jun-26</a:t>
+              <a:t>23-Jun-26</a:t>
             </a:fld>
             <a:endParaRPr lang="en-US"/>
           </a:p>
@@ -1150,7 +1157,7 @@
           <a:p>
             <a:fld id="{230516DF-AA08-42DB-AE84-024A6CB5A4E7}" type="datetimeFigureOut">
               <a:rPr lang="en-US" smtClean="0"/>
-              <a:t>19-Jun-26</a:t>
+              <a:t>23-Jun-26</a:t>
             </a:fld>
             <a:endParaRPr lang="en-US"/>
           </a:p>
@@ -1418,7 +1425,7 @@
           <a:p>
             <a:fld id="{230516DF-AA08-42DB-AE84-024A6CB5A4E7}" type="datetimeFigureOut">
               <a:rPr lang="en-US" smtClean="0"/>
-              <a:t>19-Jun-26</a:t>
+              <a:t>23-Jun-26</a:t>
             </a:fld>
             <a:endParaRPr lang="en-US"/>
           </a:p>
@@ -1833,7 +1840,7 @@
           <a:p>
             <a:fld id="{230516DF-AA08-42DB-AE84-024A6CB5A4E7}" type="datetimeFigureOut">
               <a:rPr lang="en-US" smtClean="0"/>
-              <a:t>19-Jun-26</a:t>
+              <a:t>23-Jun-26</a:t>
             </a:fld>
             <a:endParaRPr lang="en-US"/>
           </a:p>
@@ -1975,7 +1982,7 @@
           <a:p>
             <a:fld id="{230516DF-AA08-42DB-AE84-024A6CB5A4E7}" type="datetimeFigureOut">
               <a:rPr lang="en-US" smtClean="0"/>
-              <a:t>19-Jun-26</a:t>
+              <a:t>23-Jun-26</a:t>
             </a:fld>
             <a:endParaRPr lang="en-US"/>
           </a:p>
@@ -2088,7 +2095,7 @@
           <a:p>
             <a:fld id="{230516DF-AA08-42DB-AE84-024A6CB5A4E7}" type="datetimeFigureOut">
               <a:rPr lang="en-US" smtClean="0"/>
-              <a:t>19-Jun-26</a:t>
+              <a:t>23-Jun-26</a:t>
             </a:fld>
             <a:endParaRPr lang="en-US"/>
           </a:p>
@@ -2401,7 +2408,7 @@
           <a:p>
             <a:fld id="{230516DF-AA08-42DB-AE84-024A6CB5A4E7}" type="datetimeFigureOut">
               <a:rPr lang="en-US" smtClean="0"/>
-              <a:t>19-Jun-26</a:t>
+              <a:t>23-Jun-26</a:t>
             </a:fld>
             <a:endParaRPr lang="en-US"/>
           </a:p>
@@ -2690,7 +2697,7 @@
           <a:p>
             <a:fld id="{230516DF-AA08-42DB-AE84-024A6CB5A4E7}" type="datetimeFigureOut">
               <a:rPr lang="en-US" smtClean="0"/>
-              <a:t>19-Jun-26</a:t>
+              <a:t>23-Jun-26</a:t>
             </a:fld>
             <a:endParaRPr lang="en-US"/>
           </a:p>
@@ -2933,7 +2940,7 @@
           <a:p>
             <a:fld id="{230516DF-AA08-42DB-AE84-024A6CB5A4E7}" type="datetimeFigureOut">
               <a:rPr lang="en-US" smtClean="0"/>
-              <a:t>19-Jun-26</a:t>
+              <a:t>23-Jun-26</a:t>
             </a:fld>
             <a:endParaRPr lang="en-US"/>
           </a:p>
@@ -3366,9 +3373,16 @@
             <p:ph type="ctrTitle"/>
           </p:nvPr>
         </p:nvSpPr>
-        <p:spPr/>
-        <p:txBody>
-          <a:bodyPr/>
+        <p:spPr>
+          <a:xfrm>
+            <a:off x="200527" y="1122363"/>
+            <a:ext cx="11790946" cy="2711700"/>
+          </a:xfrm>
+        </p:spPr>
+        <p:txBody>
+          <a:bodyPr>
+            <a:normAutofit fontScale="90000"/>
+          </a:bodyPr>
           <a:lstStyle/>
           <a:p>
             <a:r>
@@ -3382,6 +3396,61 @@
             <a:r>
               <a:rPr lang="en-US" dirty="0" err="1"/>
               <a:t>Axelroda</a:t>
+            </a:r>
+            <a:br>
+              <a:rPr lang="pl-PL" dirty="0"/>
+            </a:br>
+            <a:r>
+              <a:rPr lang="en-US" sz="3600" dirty="0" err="1"/>
+              <a:t>Badanie</a:t>
+            </a:r>
+            <a:r>
+              <a:rPr lang="en-US" sz="3600" dirty="0"/>
+              <a:t> </a:t>
+            </a:r>
+            <a:r>
+              <a:rPr lang="en-US" sz="3600" dirty="0" err="1"/>
+              <a:t>wpływu</a:t>
+            </a:r>
+            <a:r>
+              <a:rPr lang="en-US" sz="3600" dirty="0"/>
+              <a:t> </a:t>
+            </a:r>
+            <a:r>
+              <a:rPr lang="en-US" sz="3600" dirty="0" err="1"/>
+              <a:t>homofilii</a:t>
+            </a:r>
+            <a:r>
+              <a:rPr lang="en-US" sz="3600" dirty="0"/>
+              <a:t> </a:t>
+            </a:r>
+            <a:r>
+              <a:rPr lang="en-US" sz="3600" dirty="0" err="1"/>
+              <a:t>na</a:t>
+            </a:r>
+            <a:r>
+              <a:rPr lang="en-US" sz="3600" dirty="0"/>
+              <a:t> </a:t>
+            </a:r>
+            <a:r>
+              <a:rPr lang="en-US" sz="3600" dirty="0" err="1"/>
+              <a:t>trwałość</a:t>
+            </a:r>
+            <a:r>
+              <a:rPr lang="en-US" sz="3600" dirty="0"/>
+              <a:t> </a:t>
+            </a:r>
+            <a:r>
+              <a:rPr lang="en-US" sz="3600" dirty="0" err="1"/>
+              <a:t>różnorodności</a:t>
+            </a:r>
+            <a:r>
+              <a:rPr lang="en-US" sz="3600" dirty="0"/>
+              <a:t> </a:t>
+            </a:r>
+            <a:r>
+              <a:rPr lang="en-US" sz="3600" dirty="0" err="1"/>
+              <a:t>kulturowej</a:t>
             </a:r>
             <a:br>
               <a:rPr lang="en-US" dirty="0"/>
@@ -3406,7 +3475,12 @@
             <p:ph type="subTitle" idx="1"/>
           </p:nvPr>
         </p:nvSpPr>
-        <p:spPr/>
+        <p:spPr>
+          <a:xfrm>
+            <a:off x="1532020" y="4907756"/>
+            <a:ext cx="9144000" cy="1655762"/>
+          </a:xfrm>
+        </p:spPr>
         <p:txBody>
           <a:bodyPr>
             <a:normAutofit lnSpcReduction="10000"/>
@@ -3476,6 +3550,740 @@
     <p:extLst>
       <p:ext uri="{BB962C8B-B14F-4D97-AF65-F5344CB8AC3E}">
         <p14:creationId xmlns:p14="http://schemas.microsoft.com/office/powerpoint/2010/main" val="525732046"/>
+      </p:ext>
+    </p:extLst>
+  </p:cSld>
+  <p:clrMapOvr>
+    <a:masterClrMapping/>
+  </p:clrMapOvr>
+</p:sld>
+</file>
+
+<file path=ppt/slides/slide10.xml><?xml version="1.0" encoding="utf-8"?>
+<p:sld xmlns:a="http://schemas.openxmlformats.org/drawingml/2006/main" xmlns:r="http://schemas.openxmlformats.org/officeDocument/2006/relationships" xmlns:p="http://schemas.openxmlformats.org/presentationml/2006/main">
+  <p:cSld>
+    <p:spTree>
+      <p:nvGrpSpPr>
+        <p:cNvPr id="1" name="">
+          <a:extLst>
+            <a:ext uri="{FF2B5EF4-FFF2-40B4-BE49-F238E27FC236}">
+              <a16:creationId xmlns:a16="http://schemas.microsoft.com/office/drawing/2014/main" id="{371A5F96-3E07-ED20-3338-B070932A3402}"/>
+            </a:ext>
+          </a:extLst>
+        </p:cNvPr>
+        <p:cNvGrpSpPr/>
+        <p:nvPr/>
+      </p:nvGrpSpPr>
+      <p:grpSpPr>
+        <a:xfrm>
+          <a:off x="0" y="0"/>
+          <a:ext cx="0" cy="0"/>
+          <a:chOff x="0" y="0"/>
+          <a:chExt cx="0" cy="0"/>
+        </a:xfrm>
+      </p:grpSpPr>
+      <p:sp>
+        <p:nvSpPr>
+          <p:cNvPr id="4" name="pole tekstowe 3">
+            <a:extLst>
+              <a:ext uri="{FF2B5EF4-FFF2-40B4-BE49-F238E27FC236}">
+                <a16:creationId xmlns:a16="http://schemas.microsoft.com/office/drawing/2014/main" id="{7F79C7B7-EDAF-2875-B6A9-B59B7B014C1F}"/>
+              </a:ext>
+            </a:extLst>
+          </p:cNvPr>
+          <p:cNvSpPr txBox="1"/>
+          <p:nvPr/>
+        </p:nvSpPr>
+        <p:spPr>
+          <a:xfrm>
+            <a:off x="4748463" y="545431"/>
+            <a:ext cx="4812632" cy="584775"/>
+          </a:xfrm>
+          <a:prstGeom prst="rect">
+            <a:avLst/>
+          </a:prstGeom>
+          <a:noFill/>
+        </p:spPr>
+        <p:txBody>
+          <a:bodyPr wrap="square" rtlCol="0">
+            <a:spAutoFit/>
+          </a:bodyPr>
+          <a:lstStyle/>
+          <a:p>
+            <a:r>
+              <a:rPr lang="pl-PL" sz="3200" dirty="0"/>
+              <a:t>Symulacja B</a:t>
+            </a:r>
+            <a:endParaRPr lang="en-US" sz="3200" dirty="0"/>
+          </a:p>
+        </p:txBody>
+      </p:sp>
+      <p:pic>
+        <p:nvPicPr>
+          <p:cNvPr id="5" name="Obraz 4">
+            <a:extLst>
+              <a:ext uri="{FF2B5EF4-FFF2-40B4-BE49-F238E27FC236}">
+                <a16:creationId xmlns:a16="http://schemas.microsoft.com/office/drawing/2014/main" id="{BAE61DAC-EC9F-4311-0B8B-E18BB0CE6723}"/>
+              </a:ext>
+            </a:extLst>
+          </p:cNvPr>
+          <p:cNvPicPr>
+            <a:picLocks noChangeAspect="1"/>
+          </p:cNvPicPr>
+          <p:nvPr/>
+        </p:nvPicPr>
+        <p:blipFill>
+          <a:blip r:embed="rId2"/>
+          <a:stretch>
+            <a:fillRect/>
+          </a:stretch>
+        </p:blipFill>
+        <p:spPr>
+          <a:xfrm>
+            <a:off x="381000" y="1550069"/>
+            <a:ext cx="11430000" cy="4762500"/>
+          </a:xfrm>
+          <a:prstGeom prst="rect">
+            <a:avLst/>
+          </a:prstGeom>
+        </p:spPr>
+      </p:pic>
+    </p:spTree>
+    <p:extLst>
+      <p:ext uri="{BB962C8B-B14F-4D97-AF65-F5344CB8AC3E}">
+        <p14:creationId xmlns:p14="http://schemas.microsoft.com/office/powerpoint/2010/main" val="3745341163"/>
+      </p:ext>
+    </p:extLst>
+  </p:cSld>
+  <p:clrMapOvr>
+    <a:masterClrMapping/>
+  </p:clrMapOvr>
+</p:sld>
+</file>
+
+<file path=ppt/slides/slide11.xml><?xml version="1.0" encoding="utf-8"?>
+<p:sld xmlns:a="http://schemas.openxmlformats.org/drawingml/2006/main" xmlns:r="http://schemas.openxmlformats.org/officeDocument/2006/relationships" xmlns:p="http://schemas.openxmlformats.org/presentationml/2006/main">
+  <p:cSld>
+    <p:spTree>
+      <p:nvGrpSpPr>
+        <p:cNvPr id="1" name=""/>
+        <p:cNvGrpSpPr/>
+        <p:nvPr/>
+      </p:nvGrpSpPr>
+      <p:grpSpPr>
+        <a:xfrm>
+          <a:off x="0" y="0"/>
+          <a:ext cx="0" cy="0"/>
+          <a:chOff x="0" y="0"/>
+          <a:chExt cx="0" cy="0"/>
+        </a:xfrm>
+      </p:grpSpPr>
+      <p:sp>
+        <p:nvSpPr>
+          <p:cNvPr id="2" name="Tytuł 1">
+            <a:extLst>
+              <a:ext uri="{FF2B5EF4-FFF2-40B4-BE49-F238E27FC236}">
+                <a16:creationId xmlns:a16="http://schemas.microsoft.com/office/drawing/2014/main" id="{CB6157CB-37E3-1BAD-1464-BA515DC4B543}"/>
+              </a:ext>
+            </a:extLst>
+          </p:cNvPr>
+          <p:cNvSpPr>
+            <a:spLocks noGrp="1"/>
+          </p:cNvSpPr>
+          <p:nvPr>
+            <p:ph type="title"/>
+          </p:nvPr>
+        </p:nvSpPr>
+        <p:spPr/>
+        <p:txBody>
+          <a:bodyPr/>
+          <a:lstStyle/>
+          <a:p>
+            <a:r>
+              <a:rPr lang="pl-PL" dirty="0"/>
+              <a:t>Wnioski końcowe</a:t>
+            </a:r>
+            <a:endParaRPr lang="en-US" dirty="0"/>
+          </a:p>
+        </p:txBody>
+      </p:sp>
+      <p:sp>
+        <p:nvSpPr>
+          <p:cNvPr id="3" name="Symbol zastępczy zawartości 2">
+            <a:extLst>
+              <a:ext uri="{FF2B5EF4-FFF2-40B4-BE49-F238E27FC236}">
+                <a16:creationId xmlns:a16="http://schemas.microsoft.com/office/drawing/2014/main" id="{DE8976C9-4BCF-B715-7CBA-4FBC45D36595}"/>
+              </a:ext>
+            </a:extLst>
+          </p:cNvPr>
+          <p:cNvSpPr>
+            <a:spLocks noGrp="1"/>
+          </p:cNvSpPr>
+          <p:nvPr>
+            <p:ph idx="1"/>
+          </p:nvPr>
+        </p:nvSpPr>
+        <p:spPr>
+          <a:xfrm>
+            <a:off x="659219" y="1499191"/>
+            <a:ext cx="11206716" cy="5071730"/>
+          </a:xfrm>
+        </p:spPr>
+        <p:txBody>
+          <a:bodyPr>
+            <a:normAutofit fontScale="25000" lnSpcReduction="20000"/>
+          </a:bodyPr>
+          <a:lstStyle/>
+          <a:p>
+            <a:r>
+              <a:rPr lang="en-US" sz="12800" dirty="0" err="1"/>
+              <a:t>Najważniejszy</a:t>
+            </a:r>
+            <a:r>
+              <a:rPr lang="en-US" sz="12800" dirty="0"/>
+              <a:t> </a:t>
+            </a:r>
+            <a:r>
+              <a:rPr lang="en-US" sz="12800" dirty="0" err="1"/>
+              <a:t>wniosek</a:t>
+            </a:r>
+            <a:r>
+              <a:rPr lang="en-US" sz="12800" dirty="0"/>
+              <a:t> </a:t>
+            </a:r>
+            <a:r>
+              <a:rPr lang="en-US" sz="12800" dirty="0" err="1"/>
+              <a:t>płynący</a:t>
+            </a:r>
+            <a:r>
+              <a:rPr lang="en-US" sz="12800" dirty="0"/>
+              <a:t> z </a:t>
+            </a:r>
+            <a:r>
+              <a:rPr lang="en-US" sz="12800" dirty="0" err="1"/>
+              <a:t>badań</a:t>
+            </a:r>
+            <a:r>
+              <a:rPr lang="en-US" sz="12800" dirty="0"/>
+              <a:t> </a:t>
+            </a:r>
+            <a:r>
+              <a:rPr lang="en-US" sz="12800" dirty="0" err="1"/>
+              <a:t>Axelroda</a:t>
+            </a:r>
+            <a:r>
+              <a:rPr lang="en-US" sz="12800" dirty="0"/>
+              <a:t> </a:t>
+            </a:r>
+            <a:r>
+              <a:rPr lang="en-US" sz="12800" dirty="0" err="1"/>
+              <a:t>wskazuje</a:t>
+            </a:r>
+            <a:r>
+              <a:rPr lang="en-US" sz="12800" dirty="0"/>
+              <a:t>, </a:t>
+            </a:r>
+            <a:r>
+              <a:rPr lang="en-US" sz="12800" dirty="0" err="1"/>
+              <a:t>że</a:t>
+            </a:r>
+            <a:r>
+              <a:rPr lang="en-US" sz="12800" dirty="0"/>
+              <a:t> </a:t>
+            </a:r>
+            <a:r>
+              <a:rPr lang="en-US" sz="12800" b="1" dirty="0" err="1"/>
+              <a:t>dążenie</a:t>
+            </a:r>
+            <a:r>
+              <a:rPr lang="en-US" sz="12800" b="1" dirty="0"/>
+              <a:t> do </a:t>
+            </a:r>
+            <a:r>
+              <a:rPr lang="en-US" sz="12800" b="1" dirty="0" err="1"/>
+              <a:t>lokalnego</a:t>
+            </a:r>
+            <a:r>
+              <a:rPr lang="en-US" sz="12800" b="1" dirty="0"/>
+              <a:t> </a:t>
+            </a:r>
+            <a:r>
+              <a:rPr lang="en-US" sz="12800" b="1" dirty="0" err="1"/>
+              <a:t>podobieństwa</a:t>
+            </a:r>
+            <a:r>
+              <a:rPr lang="pl-PL" sz="12800" b="1" dirty="0"/>
+              <a:t> </a:t>
+            </a:r>
+            <a:r>
+              <a:rPr lang="en-US" sz="12800" dirty="0" err="1"/>
+              <a:t>paradoksalnie</a:t>
+            </a:r>
+            <a:r>
+              <a:rPr lang="en-US" sz="12800" dirty="0"/>
+              <a:t> </a:t>
+            </a:r>
+            <a:r>
+              <a:rPr lang="en-US" sz="12800" b="1" dirty="0" err="1"/>
+              <a:t>uniemożliwia</a:t>
+            </a:r>
+            <a:r>
+              <a:rPr lang="en-US" sz="12800" b="1" dirty="0"/>
+              <a:t> </a:t>
+            </a:r>
+            <a:r>
+              <a:rPr lang="en-US" sz="12800" b="1" dirty="0" err="1"/>
+              <a:t>całkowite</a:t>
+            </a:r>
+            <a:r>
+              <a:rPr lang="en-US" sz="12800" b="1" dirty="0"/>
+              <a:t> </a:t>
+            </a:r>
+            <a:r>
+              <a:rPr lang="en-US" sz="12800" b="1" dirty="0" err="1"/>
+              <a:t>ujednolicenie</a:t>
+            </a:r>
+            <a:r>
+              <a:rPr lang="en-US" sz="12800" b="1" dirty="0"/>
+              <a:t> </a:t>
+            </a:r>
+            <a:r>
+              <a:rPr lang="en-US" sz="12800" b="1" dirty="0" err="1"/>
+              <a:t>całego</a:t>
+            </a:r>
+            <a:r>
+              <a:rPr lang="en-US" sz="12800" b="1" dirty="0"/>
+              <a:t> </a:t>
+            </a:r>
+            <a:r>
+              <a:rPr lang="en-US" sz="12800" b="1" dirty="0" err="1"/>
+              <a:t>społeczeństwa</a:t>
+            </a:r>
+            <a:r>
+              <a:rPr lang="en-US" sz="12800" b="1" dirty="0"/>
+              <a:t> </a:t>
+            </a:r>
+            <a:r>
+              <a:rPr lang="en-US" sz="12800" dirty="0" err="1"/>
+              <a:t>i</a:t>
+            </a:r>
+            <a:r>
+              <a:rPr lang="en-US" sz="12800" dirty="0"/>
+              <a:t> </a:t>
+            </a:r>
+            <a:r>
+              <a:rPr lang="en-US" sz="12800" dirty="0" err="1"/>
+              <a:t>cementuje</a:t>
+            </a:r>
+            <a:r>
+              <a:rPr lang="en-US" sz="12800" dirty="0"/>
+              <a:t>  </a:t>
+            </a:r>
+            <a:r>
+              <a:rPr lang="en-US" sz="12800" dirty="0" err="1"/>
+              <a:t>trwałe</a:t>
+            </a:r>
+            <a:r>
+              <a:rPr lang="en-US" sz="12800" dirty="0"/>
+              <a:t> </a:t>
+            </a:r>
+            <a:r>
+              <a:rPr lang="en-US" sz="12800" dirty="0" err="1"/>
+              <a:t>podziały</a:t>
+            </a:r>
+            <a:r>
+              <a:rPr lang="en-US" sz="12800" dirty="0"/>
+              <a:t> </a:t>
+            </a:r>
+            <a:r>
+              <a:rPr lang="en-US" sz="12800" dirty="0" err="1"/>
+              <a:t>kulturowe</a:t>
+            </a:r>
+            <a:r>
+              <a:rPr lang="en-US" sz="12800" dirty="0"/>
+              <a:t> </a:t>
+            </a:r>
+            <a:r>
+              <a:rPr lang="en-US" sz="12800" dirty="0" err="1"/>
+              <a:t>na</a:t>
+            </a:r>
+            <a:r>
+              <a:rPr lang="en-US" sz="12800" dirty="0"/>
+              <a:t> </a:t>
+            </a:r>
+            <a:r>
+              <a:rPr lang="en-US" sz="12800" dirty="0" err="1"/>
+              <a:t>poziomie</a:t>
+            </a:r>
+            <a:r>
+              <a:rPr lang="en-US" sz="12800" dirty="0"/>
+              <a:t> </a:t>
+            </a:r>
+            <a:r>
+              <a:rPr lang="en-US" sz="12800" dirty="0" err="1"/>
+              <a:t>globalnym</a:t>
+            </a:r>
+            <a:r>
+              <a:rPr lang="en-US" sz="12800" dirty="0"/>
+              <a:t> (</a:t>
+            </a:r>
+            <a:r>
+              <a:rPr lang="en-US" sz="12800" dirty="0" err="1"/>
+              <a:t>wyspy</a:t>
+            </a:r>
+            <a:r>
+              <a:rPr lang="en-US" sz="12800" dirty="0"/>
+              <a:t> </a:t>
+            </a:r>
+            <a:r>
+              <a:rPr lang="en-US" sz="12800" dirty="0" err="1"/>
+              <a:t>wspólne</a:t>
+            </a:r>
+            <a:r>
+              <a:rPr lang="en-US" sz="12800" dirty="0"/>
+              <a:t> </a:t>
+            </a:r>
+            <a:r>
+              <a:rPr lang="en-US" sz="12800" dirty="0" err="1"/>
+              <a:t>kulturowo</a:t>
+            </a:r>
+            <a:r>
+              <a:rPr lang="en-US" sz="12800" dirty="0"/>
+              <a:t>).</a:t>
+            </a:r>
+            <a:br>
+              <a:rPr lang="en-US" sz="12800" dirty="0"/>
+            </a:br>
+            <a:endParaRPr lang="en-US" sz="12800" dirty="0"/>
+          </a:p>
+          <a:p>
+            <a:r>
+              <a:rPr lang="en-US" sz="12800" dirty="0"/>
+              <a:t>    </a:t>
+            </a:r>
+            <a:r>
+              <a:rPr lang="en-US" sz="12800" dirty="0" err="1"/>
+              <a:t>Im</a:t>
+            </a:r>
+            <a:r>
+              <a:rPr lang="en-US" sz="12800" dirty="0"/>
+              <a:t> </a:t>
+            </a:r>
+            <a:r>
+              <a:rPr lang="en-US" sz="12800" b="1" dirty="0" err="1"/>
+              <a:t>więcej</a:t>
+            </a:r>
+            <a:r>
+              <a:rPr lang="en-US" sz="12800" b="1" dirty="0"/>
+              <a:t> </a:t>
+            </a:r>
+            <a:r>
+              <a:rPr lang="en-US" sz="12800" b="1" dirty="0" err="1"/>
+              <a:t>cech</a:t>
+            </a:r>
+            <a:r>
+              <a:rPr lang="en-US" sz="12800" b="1" dirty="0"/>
+              <a:t> </a:t>
+            </a:r>
+            <a:r>
+              <a:rPr lang="en-US" sz="12800" dirty="0" err="1"/>
+              <a:t>opisuje</a:t>
+            </a:r>
+            <a:r>
+              <a:rPr lang="en-US" sz="12800" dirty="0"/>
+              <a:t> </a:t>
+            </a:r>
+            <a:r>
+              <a:rPr lang="en-US" sz="12800" dirty="0" err="1"/>
+              <a:t>kulturę</a:t>
+            </a:r>
+            <a:r>
+              <a:rPr lang="en-US" sz="12800" dirty="0"/>
+              <a:t>, </a:t>
+            </a:r>
+            <a:r>
+              <a:rPr lang="en-US" sz="12800" dirty="0" err="1"/>
+              <a:t>tym</a:t>
+            </a:r>
+            <a:r>
+              <a:rPr lang="en-US" sz="12800" dirty="0"/>
+              <a:t> </a:t>
+            </a:r>
+            <a:r>
+              <a:rPr lang="en-US" sz="12800" b="1" dirty="0" err="1"/>
+              <a:t>mniej</a:t>
+            </a:r>
+            <a:r>
+              <a:rPr lang="en-US" sz="12800" b="1" dirty="0"/>
+              <a:t> </a:t>
+            </a:r>
+            <a:r>
+              <a:rPr lang="en-US" sz="12800" b="1" dirty="0" err="1"/>
+              <a:t>stabilnych</a:t>
+            </a:r>
+            <a:r>
+              <a:rPr lang="en-US" sz="12800" b="1" dirty="0"/>
+              <a:t> </a:t>
+            </a:r>
+            <a:r>
+              <a:rPr lang="en-US" sz="12800" b="1" dirty="0" err="1"/>
+              <a:t>regionów</a:t>
+            </a:r>
+            <a:r>
+              <a:rPr lang="en-US" sz="12800" b="1" dirty="0"/>
+              <a:t> </a:t>
+            </a:r>
+            <a:r>
+              <a:rPr lang="en-US" sz="12800" b="1" dirty="0" err="1"/>
+              <a:t>kulturowych</a:t>
+            </a:r>
+            <a:r>
+              <a:rPr lang="en-US" sz="12800" b="1" dirty="0"/>
+              <a:t> </a:t>
+            </a:r>
+            <a:r>
+              <a:rPr lang="en-US" sz="12800" dirty="0" err="1"/>
+              <a:t>pozostaje</a:t>
+            </a:r>
+            <a:r>
+              <a:rPr lang="en-US" sz="12800" dirty="0"/>
+              <a:t> </a:t>
+            </a:r>
+            <a:r>
+              <a:rPr lang="en-US" sz="12800" dirty="0" err="1"/>
+              <a:t>na</a:t>
+            </a:r>
+            <a:r>
+              <a:rPr lang="en-US" sz="12800" dirty="0"/>
+              <a:t> </a:t>
+            </a:r>
+            <a:r>
+              <a:rPr lang="en-US" sz="12800" dirty="0" err="1"/>
+              <a:t>końcu</a:t>
+            </a:r>
+            <a:r>
+              <a:rPr lang="en-US" sz="12800" dirty="0"/>
+              <a:t> (</a:t>
+            </a:r>
+            <a:r>
+              <a:rPr lang="en-US" sz="12800" dirty="0" err="1"/>
+              <a:t>sprzeczne</a:t>
+            </a:r>
+            <a:r>
+              <a:rPr lang="en-US" sz="12800" dirty="0"/>
+              <a:t> z </a:t>
+            </a:r>
+            <a:r>
+              <a:rPr lang="en-US" sz="12800" dirty="0" err="1"/>
+              <a:t>intuicją</a:t>
+            </a:r>
+            <a:r>
+              <a:rPr lang="en-US" sz="12800" dirty="0"/>
+              <a:t>). </a:t>
+            </a:r>
+            <a:r>
+              <a:rPr lang="en-US" sz="12800" dirty="0" err="1"/>
+              <a:t>Dzieje</a:t>
+            </a:r>
+            <a:r>
+              <a:rPr lang="en-US" sz="12800" dirty="0"/>
+              <a:t> </a:t>
+            </a:r>
+            <a:r>
+              <a:rPr lang="en-US" sz="12800" dirty="0" err="1"/>
+              <a:t>się</a:t>
+            </a:r>
+            <a:r>
+              <a:rPr lang="en-US" sz="12800" dirty="0"/>
+              <a:t> </a:t>
+            </a:r>
+            <a:r>
+              <a:rPr lang="en-US" sz="12800" dirty="0" err="1"/>
+              <a:t>tak</a:t>
+            </a:r>
+            <a:r>
+              <a:rPr lang="en-US" sz="12800" dirty="0"/>
+              <a:t>, </a:t>
+            </a:r>
+            <a:r>
+              <a:rPr lang="en-US" sz="12800" dirty="0" err="1"/>
+              <a:t>ponieważ</a:t>
+            </a:r>
+            <a:r>
+              <a:rPr lang="en-US" sz="12800" dirty="0"/>
+              <a:t> </a:t>
+            </a:r>
+            <a:r>
+              <a:rPr lang="en-US" sz="12800" dirty="0" err="1"/>
+              <a:t>większa</a:t>
+            </a:r>
+            <a:r>
+              <a:rPr lang="en-US" sz="12800" dirty="0"/>
+              <a:t> </a:t>
+            </a:r>
+            <a:r>
+              <a:rPr lang="en-US" sz="12800" dirty="0" err="1"/>
+              <a:t>liczba</a:t>
+            </a:r>
+            <a:r>
+              <a:rPr lang="en-US" sz="12800" dirty="0"/>
+              <a:t> </a:t>
+            </a:r>
+            <a:r>
+              <a:rPr lang="en-US" sz="12800" dirty="0" err="1"/>
+              <a:t>cech</a:t>
+            </a:r>
+            <a:r>
+              <a:rPr lang="en-US" sz="12800" dirty="0"/>
+              <a:t> </a:t>
+            </a:r>
+            <a:r>
+              <a:rPr lang="en-US" sz="12800" dirty="0" err="1"/>
+              <a:t>statystycznie</a:t>
+            </a:r>
+            <a:r>
+              <a:rPr lang="pl-PL" sz="12800" dirty="0"/>
+              <a:t> </a:t>
+            </a:r>
+            <a:r>
+              <a:rPr lang="en-US" sz="12800" dirty="0" err="1"/>
+              <a:t>zwiększa</a:t>
+            </a:r>
+            <a:r>
+              <a:rPr lang="en-US" sz="12800" dirty="0"/>
+              <a:t> </a:t>
+            </a:r>
+            <a:r>
+              <a:rPr lang="en-US" sz="12800" dirty="0" err="1"/>
+              <a:t>szansę</a:t>
+            </a:r>
+            <a:r>
+              <a:rPr lang="en-US" sz="12800" dirty="0"/>
+              <a:t> </a:t>
+            </a:r>
+            <a:r>
+              <a:rPr lang="en-US" sz="12800" dirty="0" err="1"/>
+              <a:t>posiadania</a:t>
+            </a:r>
+            <a:r>
+              <a:rPr lang="en-US" sz="12800" dirty="0"/>
+              <a:t> </a:t>
+            </a:r>
+            <a:r>
+              <a:rPr lang="en-US" sz="12800" dirty="0" err="1"/>
+              <a:t>jednego</a:t>
+            </a:r>
+            <a:r>
+              <a:rPr lang="en-US" sz="12800" dirty="0"/>
+              <a:t> </a:t>
+            </a:r>
+            <a:r>
+              <a:rPr lang="en-US" sz="12800" dirty="0" err="1"/>
+              <a:t>wspólnego</a:t>
+            </a:r>
+            <a:r>
+              <a:rPr lang="en-US" sz="12800" dirty="0"/>
+              <a:t> </a:t>
+            </a:r>
+            <a:r>
+              <a:rPr lang="en-US" sz="12800" dirty="0" err="1"/>
+              <a:t>elementu</a:t>
+            </a:r>
+            <a:r>
+              <a:rPr lang="en-US" sz="12800" dirty="0"/>
+              <a:t>, </a:t>
+            </a:r>
+            <a:r>
+              <a:rPr lang="en-US" sz="12800" dirty="0" err="1"/>
+              <a:t>czyli</a:t>
+            </a:r>
+            <a:r>
+              <a:rPr lang="en-US" sz="12800" dirty="0"/>
+              <a:t> </a:t>
+            </a:r>
+            <a:r>
+              <a:rPr lang="en-US" sz="12800" dirty="0" err="1"/>
+              <a:t>umożliwia</a:t>
+            </a:r>
+            <a:r>
+              <a:rPr lang="en-US" sz="12800" dirty="0"/>
+              <a:t> </a:t>
+            </a:r>
+            <a:r>
+              <a:rPr lang="en-US" sz="12800" dirty="0" err="1"/>
+              <a:t>interakcje</a:t>
+            </a:r>
+            <a:r>
+              <a:rPr lang="pl-PL" sz="12800" dirty="0"/>
+              <a:t> </a:t>
+            </a:r>
+            <a:r>
+              <a:rPr lang="en-US" sz="12800" dirty="0" err="1"/>
+              <a:t>i</a:t>
+            </a:r>
+            <a:r>
+              <a:rPr lang="en-US" sz="12800" dirty="0"/>
+              <a:t> </a:t>
+            </a:r>
+            <a:r>
+              <a:rPr lang="en-US" sz="12800" dirty="0" err="1"/>
+              <a:t>dalsze</a:t>
+            </a:r>
+            <a:r>
+              <a:rPr lang="en-US" sz="12800" dirty="0"/>
+              <a:t> </a:t>
+            </a:r>
+            <a:r>
+              <a:rPr lang="en-US" sz="12800" dirty="0" err="1"/>
+              <a:t>zwiększanie</a:t>
+            </a:r>
+            <a:r>
+              <a:rPr lang="en-US" sz="12800" dirty="0"/>
+              <a:t> </a:t>
+            </a:r>
+            <a:r>
+              <a:rPr lang="en-US" sz="12800" dirty="0" err="1"/>
+              <a:t>liczby</a:t>
+            </a:r>
+            <a:r>
+              <a:rPr lang="en-US" sz="12800" dirty="0"/>
+              <a:t> </a:t>
+            </a:r>
+            <a:r>
+              <a:rPr lang="en-US" sz="12800" dirty="0" err="1"/>
+              <a:t>wspólnych</a:t>
+            </a:r>
+            <a:r>
+              <a:rPr lang="en-US" sz="12800" dirty="0"/>
+              <a:t> </a:t>
+            </a:r>
+            <a:r>
+              <a:rPr lang="en-US" sz="12800" dirty="0" err="1"/>
+              <a:t>cech</a:t>
+            </a:r>
+            <a:r>
+              <a:rPr lang="en-US" sz="12800" dirty="0"/>
+              <a:t>.</a:t>
+            </a:r>
+          </a:p>
+          <a:p>
+            <a:pPr marL="0" indent="0">
+              <a:buNone/>
+            </a:pPr>
+            <a:br>
+              <a:rPr lang="en-US" dirty="0"/>
+            </a:br>
+            <a:endParaRPr lang="en-US" dirty="0"/>
+          </a:p>
+          <a:p>
+            <a:endParaRPr lang="en-US" dirty="0"/>
+          </a:p>
+        </p:txBody>
+      </p:sp>
+    </p:spTree>
+    <p:extLst>
+      <p:ext uri="{BB962C8B-B14F-4D97-AF65-F5344CB8AC3E}">
+        <p14:creationId xmlns:p14="http://schemas.microsoft.com/office/powerpoint/2010/main" val="3429367521"/>
       </p:ext>
     </p:extLst>
   </p:cSld>
@@ -3507,7 +4315,7 @@
           <p:cNvPr id="2" name="Tytuł 1">
             <a:extLst>
               <a:ext uri="{FF2B5EF4-FFF2-40B4-BE49-F238E27FC236}">
-                <a16:creationId xmlns:a16="http://schemas.microsoft.com/office/drawing/2014/main" id="{6E8A4F2E-4CD2-DEF7-B12A-2E58466263FB}"/>
+                <a16:creationId xmlns:a16="http://schemas.microsoft.com/office/drawing/2014/main" id="{A273D296-8A23-FD58-6805-873B5090CCAD}"/>
               </a:ext>
             </a:extLst>
           </p:cNvPr>
@@ -3518,108 +4326,249 @@
             <p:ph type="title"/>
           </p:nvPr>
         </p:nvSpPr>
-        <p:spPr/>
+        <p:spPr>
+          <a:xfrm>
+            <a:off x="831850" y="2153821"/>
+            <a:ext cx="10515600" cy="2852737"/>
+          </a:xfrm>
+        </p:spPr>
+        <p:txBody>
+          <a:bodyPr/>
+          <a:lstStyle/>
+          <a:p>
+            <a:r>
+              <a:rPr lang="pl-PL" dirty="0"/>
+              <a:t>Tło historyczne</a:t>
+            </a:r>
+            <a:endParaRPr lang="en-US" dirty="0"/>
+          </a:p>
+        </p:txBody>
+      </p:sp>
+      <p:sp>
+        <p:nvSpPr>
+          <p:cNvPr id="3" name="Symbol zastępczy tekstu 2">
+            <a:extLst>
+              <a:ext uri="{FF2B5EF4-FFF2-40B4-BE49-F238E27FC236}">
+                <a16:creationId xmlns:a16="http://schemas.microsoft.com/office/drawing/2014/main" id="{3EDA3936-6434-2E42-0EB6-4F0E766BA9AE}"/>
+              </a:ext>
+            </a:extLst>
+          </p:cNvPr>
+          <p:cNvSpPr>
+            <a:spLocks noGrp="1"/>
+          </p:cNvSpPr>
+          <p:nvPr>
+            <p:ph type="body" idx="1"/>
+          </p:nvPr>
+        </p:nvSpPr>
+        <p:spPr>
+          <a:xfrm>
+            <a:off x="831850" y="5006558"/>
+            <a:ext cx="10515600" cy="1500187"/>
+          </a:xfrm>
+        </p:spPr>
         <p:txBody>
           <a:bodyPr>
-            <a:normAutofit fontScale="90000"/>
+            <a:normAutofit/>
           </a:bodyPr>
           <a:lstStyle/>
           <a:p>
             <a:r>
-              <a:rPr lang="en-US" dirty="0" err="1"/>
-              <a:t>Badanie</a:t>
-            </a:r>
-            <a:r>
-              <a:rPr lang="en-US" dirty="0"/>
-              <a:t> </a:t>
-            </a:r>
-            <a:r>
-              <a:rPr lang="en-US" dirty="0" err="1"/>
-              <a:t>wpływu</a:t>
-            </a:r>
-            <a:r>
-              <a:rPr lang="en-US" dirty="0"/>
-              <a:t> </a:t>
-            </a:r>
-            <a:r>
-              <a:rPr lang="en-US" dirty="0" err="1"/>
-              <a:t>homofilii</a:t>
-            </a:r>
-            <a:r>
-              <a:rPr lang="en-US" dirty="0"/>
-              <a:t> </a:t>
-            </a:r>
-            <a:r>
-              <a:rPr lang="en-US" dirty="0" err="1"/>
-              <a:t>na</a:t>
-            </a:r>
-            <a:r>
-              <a:rPr lang="en-US" dirty="0"/>
-              <a:t> </a:t>
-            </a:r>
-            <a:r>
-              <a:rPr lang="en-US" dirty="0" err="1"/>
-              <a:t>trwałość</a:t>
-            </a:r>
-            <a:r>
-              <a:rPr lang="en-US" dirty="0"/>
-              <a:t> </a:t>
-            </a:r>
-            <a:r>
-              <a:rPr lang="en-US" dirty="0" err="1"/>
-              <a:t>różnorodności</a:t>
-            </a:r>
-            <a:r>
-              <a:rPr lang="en-US" dirty="0"/>
-              <a:t> </a:t>
-            </a:r>
-            <a:r>
-              <a:rPr lang="en-US" dirty="0" err="1"/>
-              <a:t>kulturowej</a:t>
-            </a:r>
-            <a:br>
-              <a:rPr lang="en-US" dirty="0"/>
-            </a:br>
-            <a:r>
-              <a:rPr lang="en-US" dirty="0"/>
-              <a:t>    </a:t>
-            </a:r>
-            <a:br>
-              <a:rPr lang="en-US" dirty="0"/>
-            </a:br>
-            <a:endParaRPr lang="en-US" dirty="0"/>
-          </a:p>
-        </p:txBody>
-      </p:sp>
-      <p:sp>
-        <p:nvSpPr>
-          <p:cNvPr id="3" name="Symbol zastępczy tekstu 2">
-            <a:extLst>
-              <a:ext uri="{FF2B5EF4-FFF2-40B4-BE49-F238E27FC236}">
-                <a16:creationId xmlns:a16="http://schemas.microsoft.com/office/drawing/2014/main" id="{2D4BCE12-5E07-4EE4-2B59-8E555A709C2B}"/>
-              </a:ext>
-            </a:extLst>
-          </p:cNvPr>
-          <p:cNvSpPr>
-            <a:spLocks noGrp="1"/>
-          </p:cNvSpPr>
-          <p:nvPr>
-            <p:ph type="body" idx="1"/>
-          </p:nvPr>
-        </p:nvSpPr>
-        <p:spPr/>
-        <p:txBody>
-          <a:bodyPr/>
-          <a:lstStyle/>
-          <a:p>
-            <a:endParaRPr lang="en-US"/>
-          </a:p>
-        </p:txBody>
-      </p:sp>
+              <a:rPr lang="en-US" sz="2800" dirty="0" err="1">
+                <a:solidFill>
+                  <a:schemeClr val="tx1"/>
+                </a:solidFill>
+              </a:rPr>
+              <a:t>Dlaczego</a:t>
+            </a:r>
+            <a:r>
+              <a:rPr lang="en-US" sz="2800" dirty="0">
+                <a:solidFill>
+                  <a:schemeClr val="tx1"/>
+                </a:solidFill>
+              </a:rPr>
+              <a:t> </a:t>
+            </a:r>
+            <a:r>
+              <a:rPr lang="en-US" sz="2800" dirty="0" err="1">
+                <a:solidFill>
+                  <a:schemeClr val="tx1"/>
+                </a:solidFill>
+              </a:rPr>
+              <a:t>mimo</a:t>
+            </a:r>
+            <a:r>
+              <a:rPr lang="en-US" sz="2800" dirty="0">
+                <a:solidFill>
+                  <a:schemeClr val="tx1"/>
+                </a:solidFill>
+              </a:rPr>
+              <a:t> </a:t>
+            </a:r>
+            <a:r>
+              <a:rPr lang="en-US" sz="2800" dirty="0" err="1">
+                <a:solidFill>
+                  <a:schemeClr val="tx1"/>
+                </a:solidFill>
+              </a:rPr>
+              <a:t>postępującej</a:t>
+            </a:r>
+            <a:r>
+              <a:rPr lang="en-US" sz="2800" dirty="0">
+                <a:solidFill>
+                  <a:schemeClr val="tx1"/>
+                </a:solidFill>
+              </a:rPr>
+              <a:t> </a:t>
+            </a:r>
+            <a:r>
+              <a:rPr lang="en-US" sz="2800" dirty="0" err="1">
+                <a:solidFill>
+                  <a:schemeClr val="tx1"/>
+                </a:solidFill>
+              </a:rPr>
+              <a:t>asymilacji</a:t>
+            </a:r>
+            <a:r>
+              <a:rPr lang="en-US" sz="2800" dirty="0">
+                <a:solidFill>
+                  <a:schemeClr val="tx1"/>
+                </a:solidFill>
+              </a:rPr>
+              <a:t> </a:t>
+            </a:r>
+            <a:r>
+              <a:rPr lang="en-US" sz="2800" dirty="0" err="1">
+                <a:solidFill>
+                  <a:schemeClr val="tx1"/>
+                </a:solidFill>
+              </a:rPr>
+              <a:t>ludzkość</a:t>
+            </a:r>
+            <a:r>
+              <a:rPr lang="en-US" sz="2800" dirty="0">
+                <a:solidFill>
+                  <a:schemeClr val="tx1"/>
+                </a:solidFill>
+              </a:rPr>
+              <a:t> </a:t>
+            </a:r>
+            <a:r>
+              <a:rPr lang="en-US" sz="2800" dirty="0" err="1">
+                <a:solidFill>
+                  <a:schemeClr val="tx1"/>
+                </a:solidFill>
+              </a:rPr>
+              <a:t>nie</a:t>
+            </a:r>
+            <a:r>
+              <a:rPr lang="en-US" sz="2800" dirty="0">
+                <a:solidFill>
+                  <a:schemeClr val="tx1"/>
+                </a:solidFill>
+              </a:rPr>
+              <a:t> </a:t>
+            </a:r>
+            <a:r>
+              <a:rPr lang="en-US" sz="2800" dirty="0" err="1">
+                <a:solidFill>
+                  <a:schemeClr val="tx1"/>
+                </a:solidFill>
+              </a:rPr>
+              <a:t>stała</a:t>
+            </a:r>
+            <a:r>
+              <a:rPr lang="en-US" sz="2800" dirty="0">
+                <a:solidFill>
+                  <a:schemeClr val="tx1"/>
+                </a:solidFill>
+              </a:rPr>
+              <a:t> </a:t>
+            </a:r>
+            <a:r>
+              <a:rPr lang="en-US" sz="2800" dirty="0" err="1">
+                <a:solidFill>
+                  <a:schemeClr val="tx1"/>
+                </a:solidFill>
+              </a:rPr>
+              <a:t>się</a:t>
+            </a:r>
+            <a:r>
+              <a:rPr lang="en-US" sz="2800" dirty="0">
+                <a:solidFill>
+                  <a:schemeClr val="tx1"/>
+                </a:solidFill>
+              </a:rPr>
+              <a:t> </a:t>
+            </a:r>
+            <a:r>
+              <a:rPr lang="en-US" sz="2800" dirty="0" err="1">
+                <a:solidFill>
+                  <a:schemeClr val="tx1"/>
+                </a:solidFill>
+              </a:rPr>
+              <a:t>jedną</a:t>
+            </a:r>
+            <a:r>
+              <a:rPr lang="en-US" sz="2800" dirty="0">
+                <a:solidFill>
+                  <a:schemeClr val="tx1"/>
+                </a:solidFill>
+              </a:rPr>
+              <a:t> </a:t>
+            </a:r>
+            <a:r>
+              <a:rPr lang="en-US" sz="2800" dirty="0" err="1">
+                <a:solidFill>
+                  <a:schemeClr val="tx1"/>
+                </a:solidFill>
+              </a:rPr>
+              <a:t>monokulturą</a:t>
+            </a:r>
+            <a:r>
+              <a:rPr lang="en-US" sz="2800" dirty="0">
+                <a:solidFill>
+                  <a:schemeClr val="tx1"/>
+                </a:solidFill>
+              </a:rPr>
+              <a:t>?</a:t>
+            </a:r>
+          </a:p>
+        </p:txBody>
+      </p:sp>
+      <p:pic>
+        <p:nvPicPr>
+          <p:cNvPr id="5" name="Obraz 4">
+            <a:extLst>
+              <a:ext uri="{FF2B5EF4-FFF2-40B4-BE49-F238E27FC236}">
+                <a16:creationId xmlns:a16="http://schemas.microsoft.com/office/drawing/2014/main" id="{268A5274-38C7-857A-15B4-0ECDB77D3103}"/>
+              </a:ext>
+            </a:extLst>
+          </p:cNvPr>
+          <p:cNvPicPr>
+            <a:picLocks noChangeAspect="1"/>
+          </p:cNvPicPr>
+          <p:nvPr/>
+        </p:nvPicPr>
+        <p:blipFill>
+          <a:blip r:embed="rId2"/>
+          <a:stretch>
+            <a:fillRect/>
+          </a:stretch>
+        </p:blipFill>
+        <p:spPr>
+          <a:xfrm>
+            <a:off x="3238500" y="41652"/>
+            <a:ext cx="5715000" cy="3810000"/>
+          </a:xfrm>
+          <a:prstGeom prst="rect">
+            <a:avLst/>
+          </a:prstGeom>
+        </p:spPr>
+      </p:pic>
     </p:spTree>
     <p:extLst>
       <p:ext uri="{BB962C8B-B14F-4D97-AF65-F5344CB8AC3E}">
-        <p14:creationId xmlns:p14="http://schemas.microsoft.com/office/powerpoint/2010/main" val="439192858"/>
+        <p14:creationId xmlns:p14="http://schemas.microsoft.com/office/powerpoint/2010/main" val="830098270"/>
       </p:ext>
     </p:extLst>
   </p:cSld>
@@ -3651,7 +4600,7 @@
           <p:cNvPr id="2" name="Tytuł 1">
             <a:extLst>
               <a:ext uri="{FF2B5EF4-FFF2-40B4-BE49-F238E27FC236}">
-                <a16:creationId xmlns:a16="http://schemas.microsoft.com/office/drawing/2014/main" id="{A273D296-8A23-FD58-6805-873B5090CCAD}"/>
+                <a16:creationId xmlns:a16="http://schemas.microsoft.com/office/drawing/2014/main" id="{4B9FA55A-7DD7-233A-B840-DBC9DD82AA75}"/>
               </a:ext>
             </a:extLst>
           </p:cNvPr>
@@ -3669,7 +4618,7 @@
           <a:p>
             <a:r>
               <a:rPr lang="pl-PL" dirty="0"/>
-              <a:t>Tło historyczne</a:t>
+              <a:t>Konstrukcja modelu</a:t>
             </a:r>
             <a:endParaRPr lang="en-US" dirty="0"/>
           </a:p>
@@ -3677,33 +4626,403 @@
       </p:sp>
       <p:sp>
         <p:nvSpPr>
-          <p:cNvPr id="3" name="Symbol zastępczy tekstu 2">
-            <a:extLst>
-              <a:ext uri="{FF2B5EF4-FFF2-40B4-BE49-F238E27FC236}">
-                <a16:creationId xmlns:a16="http://schemas.microsoft.com/office/drawing/2014/main" id="{3EDA3936-6434-2E42-0EB6-4F0E766BA9AE}"/>
-              </a:ext>
-            </a:extLst>
-          </p:cNvPr>
-          <p:cNvSpPr>
-            <a:spLocks noGrp="1"/>
-          </p:cNvSpPr>
-          <p:nvPr>
-            <p:ph type="body" idx="1"/>
+          <p:cNvPr id="3" name="Symbol zastępczy zawartości 2">
+            <a:extLst>
+              <a:ext uri="{FF2B5EF4-FFF2-40B4-BE49-F238E27FC236}">
+                <a16:creationId xmlns:a16="http://schemas.microsoft.com/office/drawing/2014/main" id="{95DC4EEC-0CDC-4AD0-EAC2-BE5C8A087146}"/>
+              </a:ext>
+            </a:extLst>
+          </p:cNvPr>
+          <p:cNvSpPr>
+            <a:spLocks noGrp="1"/>
+          </p:cNvSpPr>
+          <p:nvPr>
+            <p:ph idx="1"/>
           </p:nvPr>
         </p:nvSpPr>
         <p:spPr/>
         <p:txBody>
-          <a:bodyPr/>
+          <a:bodyPr>
+            <a:normAutofit/>
+          </a:bodyPr>
           <a:lstStyle/>
           <a:p>
-            <a:endParaRPr lang="en-US"/>
+            <a:pPr marL="514350" indent="-514350">
+              <a:buFont typeface="+mj-lt"/>
+              <a:buAutoNum type="arabicPeriod"/>
+            </a:pPr>
+            <a:r>
+              <a:rPr lang="en-US" b="1" dirty="0" err="1"/>
+              <a:t>Losowanie</a:t>
+            </a:r>
+            <a:r>
+              <a:rPr lang="en-US" dirty="0"/>
+              <a:t>: Program </a:t>
+            </a:r>
+            <a:r>
+              <a:rPr lang="en-US" dirty="0" err="1"/>
+              <a:t>wybiera</a:t>
+            </a:r>
+            <a:r>
+              <a:rPr lang="en-US" dirty="0"/>
+              <a:t> </a:t>
+            </a:r>
+            <a:r>
+              <a:rPr lang="en-US" dirty="0" err="1"/>
+              <a:t>losowo</a:t>
+            </a:r>
+            <a:r>
+              <a:rPr lang="en-US" dirty="0"/>
+              <a:t> </a:t>
+            </a:r>
+            <a:r>
+              <a:rPr lang="en-US" dirty="0" err="1"/>
+              <a:t>aktywnego</a:t>
+            </a:r>
+            <a:r>
+              <a:rPr lang="en-US" dirty="0"/>
+              <a:t> </a:t>
+            </a:r>
+            <a:r>
+              <a:rPr lang="en-US" dirty="0" err="1"/>
+              <a:t>agenta</a:t>
+            </a:r>
+            <a:r>
+              <a:rPr lang="en-US" dirty="0"/>
+              <a:t> </a:t>
+            </a:r>
+            <a:r>
+              <a:rPr lang="en-US" dirty="0" err="1"/>
+              <a:t>oraz</a:t>
+            </a:r>
+            <a:r>
+              <a:rPr lang="en-US" dirty="0"/>
+              <a:t> </a:t>
+            </a:r>
+            <a:r>
+              <a:rPr lang="en-US" dirty="0" err="1"/>
+              <a:t>jednego</a:t>
+            </a:r>
+            <a:r>
+              <a:rPr lang="en-US" dirty="0"/>
+              <a:t> z </a:t>
+            </a:r>
+            <a:r>
+              <a:rPr lang="en-US" dirty="0" err="1"/>
+              <a:t>jego</a:t>
+            </a:r>
+            <a:r>
+              <a:rPr lang="en-US" dirty="0"/>
+              <a:t> </a:t>
+            </a:r>
+            <a:r>
+              <a:rPr lang="en-US" dirty="0" err="1"/>
+              <a:t>sąsiadów</a:t>
+            </a:r>
+            <a:r>
+              <a:rPr lang="en-US" dirty="0"/>
+              <a:t>.</a:t>
+            </a:r>
+          </a:p>
+          <a:p>
+            <a:pPr marL="514350" indent="-514350">
+              <a:buFont typeface="+mj-lt"/>
+              <a:buAutoNum type="arabicPeriod"/>
+            </a:pPr>
+            <a:r>
+              <a:rPr lang="en-US" b="1" dirty="0" err="1"/>
+              <a:t>Prawdopodobieństwo</a:t>
+            </a:r>
+            <a:r>
+              <a:rPr lang="en-US" b="1" dirty="0"/>
+              <a:t> </a:t>
+            </a:r>
+            <a:r>
+              <a:rPr lang="en-US" b="1" dirty="0" err="1"/>
+              <a:t>interakcji</a:t>
+            </a:r>
+            <a:r>
+              <a:rPr lang="en-US" dirty="0"/>
+              <a:t>: </a:t>
+            </a:r>
+            <a:r>
+              <a:rPr lang="en-US" dirty="0" err="1"/>
+              <a:t>agenci</a:t>
+            </a:r>
+            <a:r>
+              <a:rPr lang="en-US" dirty="0"/>
+              <a:t> </a:t>
+            </a:r>
+            <a:r>
+              <a:rPr lang="en-US" dirty="0" err="1"/>
+              <a:t>wejdą</a:t>
+            </a:r>
+            <a:r>
+              <a:rPr lang="en-US" dirty="0"/>
+              <a:t> w </a:t>
+            </a:r>
+            <a:r>
+              <a:rPr lang="en-US" dirty="0" err="1"/>
+              <a:t>interakcję</a:t>
+            </a:r>
+            <a:r>
+              <a:rPr lang="en-US" dirty="0"/>
+              <a:t> w </a:t>
+            </a:r>
+            <a:r>
+              <a:rPr lang="en-US" dirty="0" err="1"/>
+              <a:t>zależności</a:t>
+            </a:r>
+            <a:r>
+              <a:rPr lang="en-US" dirty="0"/>
+              <a:t> </a:t>
+            </a:r>
+            <a:r>
+              <a:rPr lang="pl-PL" dirty="0"/>
+              <a:t> </a:t>
+            </a:r>
+            <a:r>
+              <a:rPr lang="en-US" dirty="0"/>
+              <a:t>od </a:t>
+            </a:r>
+            <a:r>
+              <a:rPr lang="en-US" dirty="0" err="1"/>
+              <a:t>aktualnego</a:t>
+            </a:r>
+            <a:r>
+              <a:rPr lang="en-US" dirty="0"/>
+              <a:t> </a:t>
+            </a:r>
+            <a:r>
+              <a:rPr lang="en-US" dirty="0" err="1"/>
+              <a:t>podobieństwa</a:t>
+            </a:r>
+            <a:r>
+              <a:rPr lang="en-US" dirty="0"/>
+              <a:t> </a:t>
+            </a:r>
+            <a:r>
+              <a:rPr lang="en-US" dirty="0" err="1"/>
+              <a:t>kulturowego</a:t>
+            </a:r>
+            <a:r>
+              <a:rPr lang="en-US" dirty="0"/>
+              <a:t> (np. </a:t>
+            </a:r>
+            <a:r>
+              <a:rPr lang="en-US" dirty="0" err="1"/>
+              <a:t>dla</a:t>
+            </a:r>
+            <a:r>
+              <a:rPr lang="en-US" dirty="0"/>
+              <a:t> 3 </a:t>
+            </a:r>
+            <a:r>
+              <a:rPr lang="en-US" dirty="0" err="1"/>
+              <a:t>cech</a:t>
+            </a:r>
+            <a:r>
+              <a:rPr lang="en-US" dirty="0"/>
+              <a:t> </a:t>
+            </a:r>
+            <a:r>
+              <a:rPr lang="en-US" dirty="0" err="1"/>
+              <a:t>wspólnych</a:t>
+            </a:r>
+            <a:r>
+              <a:rPr lang="en-US" dirty="0"/>
+              <a:t> </a:t>
+            </a:r>
+            <a:r>
+              <a:rPr lang="en-US" dirty="0" err="1"/>
+              <a:t>na</a:t>
+            </a:r>
+            <a:r>
+              <a:rPr lang="en-US" dirty="0"/>
+              <a:t> 5 </a:t>
+            </a:r>
+            <a:r>
+              <a:rPr lang="en-US" dirty="0" err="1"/>
+              <a:t>prawdopodobieństwo</a:t>
+            </a:r>
+            <a:r>
+              <a:rPr lang="en-US" dirty="0"/>
+              <a:t> </a:t>
+            </a:r>
+            <a:r>
+              <a:rPr lang="en-US" dirty="0" err="1"/>
+              <a:t>wynosi</a:t>
+            </a:r>
+            <a:r>
+              <a:rPr lang="en-US" dirty="0"/>
+              <a:t> 60\%, a </a:t>
+            </a:r>
+            <a:r>
+              <a:rPr lang="en-US" dirty="0" err="1"/>
+              <a:t>gdy</a:t>
+            </a:r>
+            <a:r>
+              <a:rPr lang="en-US" dirty="0"/>
+              <a:t> </a:t>
+            </a:r>
+            <a:r>
+              <a:rPr lang="en-US" dirty="0" err="1"/>
+              <a:t>brak</a:t>
+            </a:r>
+            <a:r>
+              <a:rPr lang="en-US" dirty="0"/>
+              <a:t> </a:t>
+            </a:r>
+            <a:r>
+              <a:rPr lang="en-US" dirty="0" err="1"/>
+              <a:t>wspólnych</a:t>
+            </a:r>
+            <a:r>
+              <a:rPr lang="en-US" dirty="0"/>
+              <a:t> to </a:t>
+            </a:r>
+            <a:r>
+              <a:rPr lang="en-US" dirty="0" err="1"/>
+              <a:t>nie</a:t>
+            </a:r>
+            <a:r>
+              <a:rPr lang="en-US" dirty="0"/>
+              <a:t> </a:t>
+            </a:r>
+            <a:r>
+              <a:rPr lang="en-US" dirty="0" err="1"/>
+              <a:t>dochodzi</a:t>
+            </a:r>
+            <a:r>
+              <a:rPr lang="en-US" dirty="0"/>
+              <a:t> do </a:t>
+            </a:r>
+            <a:r>
+              <a:rPr lang="en-US" dirty="0" err="1"/>
+              <a:t>interakcji</a:t>
+            </a:r>
+            <a:r>
+              <a:rPr lang="en-US" dirty="0"/>
+              <a:t>).</a:t>
+            </a:r>
+          </a:p>
+          <a:p>
+            <a:pPr marL="514350" indent="-514350">
+              <a:buFont typeface="+mj-lt"/>
+              <a:buAutoNum type="arabicPeriod"/>
+            </a:pPr>
+            <a:r>
+              <a:rPr lang="en-US" b="1" dirty="0" err="1"/>
+              <a:t>Modyfikacja</a:t>
+            </a:r>
+            <a:r>
+              <a:rPr lang="en-US" b="1" dirty="0"/>
+              <a:t> </a:t>
+            </a:r>
+            <a:r>
+              <a:rPr lang="en-US" b="1" dirty="0" err="1"/>
+              <a:t>cechy</a:t>
+            </a:r>
+            <a:r>
+              <a:rPr lang="en-US" b="1" dirty="0"/>
+              <a:t>: </a:t>
+            </a:r>
+            <a:r>
+              <a:rPr lang="en-US" dirty="0"/>
+              <a:t>agent </a:t>
+            </a:r>
+            <a:r>
+              <a:rPr lang="en-US" dirty="0" err="1"/>
+              <a:t>losowo</a:t>
+            </a:r>
+            <a:r>
+              <a:rPr lang="en-US" dirty="0"/>
+              <a:t> </a:t>
+            </a:r>
+            <a:r>
+              <a:rPr lang="en-US" dirty="0" err="1"/>
+              <a:t>przyjmuje</a:t>
+            </a:r>
+            <a:r>
+              <a:rPr lang="en-US" dirty="0"/>
+              <a:t> </a:t>
+            </a:r>
+            <a:r>
+              <a:rPr lang="en-US" dirty="0" err="1"/>
+              <a:t>jedną</a:t>
+            </a:r>
+            <a:r>
+              <a:rPr lang="en-US" dirty="0"/>
+              <a:t> </a:t>
+            </a:r>
+            <a:r>
+              <a:rPr lang="en-US" dirty="0" err="1"/>
+              <a:t>cechę</a:t>
+            </a:r>
+            <a:r>
+              <a:rPr lang="en-US" dirty="0"/>
+              <a:t> </a:t>
+            </a:r>
+            <a:r>
+              <a:rPr lang="en-US" dirty="0" err="1"/>
+              <a:t>sąsiada</a:t>
+            </a:r>
+            <a:r>
+              <a:rPr lang="en-US" dirty="0"/>
+              <a:t>, </a:t>
+            </a:r>
+            <a:r>
+              <a:rPr lang="en-US" dirty="0" err="1"/>
+              <a:t>czyli</a:t>
+            </a:r>
+            <a:r>
+              <a:rPr lang="en-US" dirty="0"/>
+              <a:t> </a:t>
+            </a:r>
+            <a:r>
+              <a:rPr lang="en-US" dirty="0" err="1"/>
+              <a:t>zwiększa</a:t>
+            </a:r>
+            <a:r>
+              <a:rPr lang="en-US" dirty="0"/>
+              <a:t> </a:t>
+            </a:r>
+            <a:r>
+              <a:rPr lang="en-US" dirty="0" err="1"/>
+              <a:t>podobieństwo</a:t>
+            </a:r>
+            <a:r>
+              <a:rPr lang="en-US" dirty="0"/>
+              <a:t> </a:t>
+            </a:r>
+            <a:r>
+              <a:rPr lang="en-US" dirty="0" err="1"/>
+              <a:t>kulturowe</a:t>
+            </a:r>
+            <a:r>
+              <a:rPr lang="en-US" dirty="0"/>
+              <a:t>.</a:t>
+            </a:r>
+          </a:p>
+          <a:p>
+            <a:pPr marL="0" indent="0">
+              <a:buNone/>
+            </a:pPr>
+            <a:endParaRPr lang="en-US" dirty="0"/>
+          </a:p>
+          <a:p>
+            <a:pPr marL="514350" indent="-514350">
+              <a:buFont typeface="+mj-lt"/>
+              <a:buAutoNum type="arabicPeriod"/>
+            </a:pPr>
+            <a:endParaRPr lang="en-US" dirty="0"/>
           </a:p>
         </p:txBody>
       </p:sp>
     </p:spTree>
     <p:extLst>
       <p:ext uri="{BB962C8B-B14F-4D97-AF65-F5344CB8AC3E}">
-        <p14:creationId xmlns:p14="http://schemas.microsoft.com/office/powerpoint/2010/main" val="830098270"/>
+        <p14:creationId xmlns:p14="http://schemas.microsoft.com/office/powerpoint/2010/main" val="3379100194"/>
       </p:ext>
     </p:extLst>
   </p:cSld>
@@ -3735,7 +5054,7 @@
           <p:cNvPr id="2" name="Tytuł 1">
             <a:extLst>
               <a:ext uri="{FF2B5EF4-FFF2-40B4-BE49-F238E27FC236}">
-                <a16:creationId xmlns:a16="http://schemas.microsoft.com/office/drawing/2014/main" id="{4B9FA55A-7DD7-233A-B840-DBC9DD82AA75}"/>
+                <a16:creationId xmlns:a16="http://schemas.microsoft.com/office/drawing/2014/main" id="{B66288A7-C2FF-EEAF-913F-879F9A76983E}"/>
               </a:ext>
             </a:extLst>
           </p:cNvPr>
@@ -3752,8 +5071,16 @@
           <a:lstStyle/>
           <a:p>
             <a:r>
-              <a:rPr lang="pl-PL" dirty="0"/>
-              <a:t>Konstrukcja modelu</a:t>
+              <a:rPr lang="en-US" dirty="0" err="1"/>
+              <a:t>Przebieg</a:t>
+            </a:r>
+            <a:r>
+              <a:rPr lang="en-US" dirty="0"/>
+              <a:t> </a:t>
+            </a:r>
+            <a:r>
+              <a:rPr lang="en-US" dirty="0" err="1"/>
+              <a:t>symulacji</a:t>
             </a:r>
             <a:endParaRPr lang="en-US" dirty="0"/>
           </a:p>
@@ -3764,7 +5091,7 @@
           <p:cNvPr id="3" name="Symbol zastępczy zawartości 2">
             <a:extLst>
               <a:ext uri="{FF2B5EF4-FFF2-40B4-BE49-F238E27FC236}">
-                <a16:creationId xmlns:a16="http://schemas.microsoft.com/office/drawing/2014/main" id="{95DC4EEC-0CDC-4AD0-EAC2-BE5C8A087146}"/>
+                <a16:creationId xmlns:a16="http://schemas.microsoft.com/office/drawing/2014/main" id="{0F17B2F8-4EF7-6C2B-E34A-76E8DFB21229}"/>
               </a:ext>
             </a:extLst>
           </p:cNvPr>
@@ -3778,7 +5105,7 @@
         <p:spPr/>
         <p:txBody>
           <a:bodyPr>
-            <a:normAutofit/>
+            <a:normAutofit fontScale="92500" lnSpcReduction="10000"/>
           </a:bodyPr>
           <a:lstStyle/>
           <a:p>
@@ -3787,76 +5114,156 @@
               <a:buAutoNum type="arabicPeriod"/>
             </a:pPr>
             <a:r>
+              <a:rPr lang="en-US" dirty="0"/>
+              <a:t>Na </a:t>
+            </a:r>
+            <a:r>
+              <a:rPr lang="en-US" dirty="0" err="1"/>
+              <a:t>początku</a:t>
+            </a:r>
+            <a:r>
+              <a:rPr lang="en-US" dirty="0"/>
+              <a:t> </a:t>
+            </a:r>
+            <a:r>
+              <a:rPr lang="en-US" dirty="0" err="1"/>
+              <a:t>agenci</a:t>
+            </a:r>
+            <a:r>
+              <a:rPr lang="en-US" dirty="0"/>
+              <a:t> </a:t>
+            </a:r>
+            <a:r>
+              <a:rPr lang="en-US" dirty="0" err="1"/>
+              <a:t>mają</a:t>
+            </a:r>
+            <a:r>
+              <a:rPr lang="en-US" dirty="0"/>
+              <a:t> </a:t>
+            </a:r>
+            <a:r>
+              <a:rPr lang="en-US" dirty="0" err="1"/>
+              <a:t>losowo</a:t>
+            </a:r>
+            <a:r>
+              <a:rPr lang="en-US" dirty="0"/>
+              <a:t> </a:t>
+            </a:r>
+            <a:r>
+              <a:rPr lang="en-US" dirty="0" err="1"/>
+              <a:t>przypisane</a:t>
+            </a:r>
+            <a:r>
+              <a:rPr lang="en-US" dirty="0"/>
+              <a:t> </a:t>
+            </a:r>
+            <a:r>
+              <a:rPr lang="en-US" dirty="0" err="1"/>
+              <a:t>warianty</a:t>
+            </a:r>
+            <a:r>
+              <a:rPr lang="en-US" dirty="0"/>
+              <a:t> </a:t>
+            </a:r>
+            <a:r>
+              <a:rPr lang="en-US" dirty="0" err="1"/>
+              <a:t>kulturowe</a:t>
+            </a:r>
+            <a:r>
+              <a:rPr lang="en-US" dirty="0"/>
+              <a:t>. </a:t>
+            </a:r>
+            <a:r>
+              <a:rPr lang="en-US" dirty="0" err="1"/>
+              <a:t>Większość</a:t>
+            </a:r>
+            <a:r>
+              <a:rPr lang="en-US" dirty="0"/>
+              <a:t> </a:t>
+            </a:r>
+            <a:r>
+              <a:rPr lang="en-US" dirty="0" err="1"/>
+              <a:t>sąsiadów</a:t>
+            </a:r>
+            <a:r>
+              <a:rPr lang="en-US" dirty="0"/>
+              <a:t> ma ze </a:t>
+            </a:r>
+            <a:r>
+              <a:rPr lang="en-US" dirty="0" err="1"/>
+              <a:t>sobą</a:t>
+            </a:r>
+            <a:r>
+              <a:rPr lang="en-US" dirty="0"/>
+              <a:t> </a:t>
+            </a:r>
+            <a:r>
               <a:rPr lang="en-US" b="1" dirty="0" err="1"/>
-              <a:t>Losowanie</a:t>
-            </a:r>
-            <a:r>
-              <a:rPr lang="en-US" dirty="0"/>
-              <a:t>: Program </a:t>
-            </a:r>
-            <a:r>
-              <a:rPr lang="en-US" dirty="0" err="1"/>
-              <a:t>wybiera</a:t>
-            </a:r>
-            <a:r>
-              <a:rPr lang="en-US" dirty="0"/>
-              <a:t> </a:t>
-            </a:r>
-            <a:r>
-              <a:rPr lang="en-US" dirty="0" err="1"/>
-              <a:t>losowo</a:t>
-            </a:r>
-            <a:r>
-              <a:rPr lang="en-US" dirty="0"/>
-              <a:t> </a:t>
-            </a:r>
-            <a:r>
-              <a:rPr lang="en-US" dirty="0" err="1"/>
-              <a:t>aktywnego</a:t>
-            </a:r>
-            <a:r>
-              <a:rPr lang="en-US" dirty="0"/>
-              <a:t> </a:t>
-            </a:r>
-            <a:r>
-              <a:rPr lang="en-US" dirty="0" err="1"/>
-              <a:t>agenta</a:t>
-            </a:r>
-            <a:r>
-              <a:rPr lang="en-US" dirty="0"/>
-              <a:t> </a:t>
-            </a:r>
-            <a:r>
-              <a:rPr lang="en-US" dirty="0" err="1"/>
-              <a:t>oraz</a:t>
-            </a:r>
-            <a:r>
-              <a:rPr lang="en-US" dirty="0"/>
-              <a:t> </a:t>
-            </a:r>
-            <a:r>
-              <a:rPr lang="en-US" dirty="0" err="1"/>
-              <a:t>jednego</a:t>
-            </a:r>
-            <a:r>
-              <a:rPr lang="en-US" dirty="0"/>
-              <a:t> z </a:t>
-            </a:r>
-            <a:r>
-              <a:rPr lang="en-US" dirty="0" err="1"/>
-              <a:t>jego</a:t>
-            </a:r>
-            <a:r>
-              <a:rPr lang="en-US" dirty="0"/>
-              <a:t> </a:t>
-            </a:r>
-            <a:r>
-              <a:rPr lang="en-US" dirty="0" err="1"/>
-              <a:t>sąsiadów</a:t>
-            </a:r>
-            <a:r>
-              <a:rPr lang="en-US" dirty="0"/>
-              <a:t>.</a:t>
+              <a:t>bardzo</a:t>
+            </a:r>
+            <a:r>
+              <a:rPr lang="en-US" b="1" dirty="0"/>
+              <a:t> </a:t>
+            </a:r>
+            <a:r>
+              <a:rPr lang="en-US" b="1" dirty="0" err="1"/>
+              <a:t>mało</a:t>
+            </a:r>
+            <a:r>
+              <a:rPr lang="en-US" b="1" dirty="0"/>
+              <a:t> </a:t>
+            </a:r>
+            <a:r>
+              <a:rPr lang="en-US" b="1" dirty="0" err="1"/>
+              <a:t>wspólnego</a:t>
+            </a:r>
+            <a:r>
+              <a:rPr lang="en-US" b="1" dirty="0"/>
+              <a:t> </a:t>
+            </a:r>
+            <a:r>
+              <a:rPr lang="en-US" dirty="0"/>
+              <a:t>(</a:t>
+            </a:r>
+            <a:r>
+              <a:rPr lang="en-US" dirty="0" err="1"/>
+              <a:t>dużo</a:t>
+            </a:r>
+            <a:r>
+              <a:rPr lang="en-US" dirty="0"/>
+              <a:t> </a:t>
+            </a:r>
+            <a:r>
+              <a:rPr lang="en-US" dirty="0" err="1"/>
+              <a:t>różnych</a:t>
+            </a:r>
+            <a:r>
+              <a:rPr lang="en-US" dirty="0"/>
+              <a:t> </a:t>
+            </a:r>
+            <a:r>
+              <a:rPr lang="en-US" dirty="0" err="1"/>
+              <a:t>kolorów</a:t>
+            </a:r>
+            <a:r>
+              <a:rPr lang="en-US" dirty="0"/>
+              <a:t> </a:t>
+            </a:r>
+            <a:r>
+              <a:rPr lang="en-US" dirty="0" err="1"/>
+              <a:t>na</a:t>
+            </a:r>
+            <a:r>
+              <a:rPr lang="en-US" dirty="0"/>
+              <a:t> </a:t>
+            </a:r>
+            <a:r>
+              <a:rPr lang="pl-PL" dirty="0"/>
+              <a:t>następnym slajdzie</a:t>
+            </a:r>
+            <a:r>
+              <a:rPr lang="en-US" dirty="0"/>
+              <a:t>).</a:t>
             </a:r>
           </a:p>
           <a:p>
@@ -3865,8 +5272,100 @@
               <a:buAutoNum type="arabicPeriod"/>
             </a:pPr>
             <a:r>
+              <a:rPr lang="en-US" dirty="0"/>
+              <a:t> W </a:t>
+            </a:r>
+            <a:r>
+              <a:rPr lang="en-US" dirty="0" err="1"/>
+              <a:t>miarę</a:t>
+            </a:r>
+            <a:r>
+              <a:rPr lang="en-US" dirty="0"/>
+              <a:t> </a:t>
+            </a:r>
+            <a:r>
+              <a:rPr lang="en-US" dirty="0" err="1"/>
+              <a:t>upływu</a:t>
+            </a:r>
+            <a:r>
+              <a:rPr lang="en-US" dirty="0"/>
+              <a:t> </a:t>
+            </a:r>
+            <a:r>
+              <a:rPr lang="en-US" dirty="0" err="1"/>
+              <a:t>czasu</a:t>
+            </a:r>
+            <a:r>
+              <a:rPr lang="en-US" dirty="0"/>
+              <a:t> (</a:t>
+            </a:r>
+            <a:r>
+              <a:rPr lang="en-US" dirty="0" err="1"/>
+              <a:t>zdarzeń</a:t>
+            </a:r>
+            <a:r>
+              <a:rPr lang="en-US" dirty="0"/>
+              <a:t>) </a:t>
+            </a:r>
+            <a:r>
+              <a:rPr lang="en-US" dirty="0" err="1"/>
+              <a:t>lokalne</a:t>
+            </a:r>
+            <a:r>
+              <a:rPr lang="en-US" dirty="0"/>
+              <a:t> </a:t>
+            </a:r>
+            <a:r>
+              <a:rPr lang="en-US" dirty="0" err="1"/>
+              <a:t>interakcje</a:t>
+            </a:r>
+            <a:r>
+              <a:rPr lang="en-US" dirty="0"/>
+              <a:t> </a:t>
+            </a:r>
+            <a:r>
+              <a:rPr lang="en-US" dirty="0" err="1"/>
+              <a:t>powodują</a:t>
+            </a:r>
+            <a:r>
+              <a:rPr lang="en-US" dirty="0"/>
+              <a:t>, </a:t>
+            </a:r>
+            <a:r>
+              <a:rPr lang="en-US" dirty="0" err="1"/>
+              <a:t>że</a:t>
+            </a:r>
+            <a:r>
+              <a:rPr lang="en-US" dirty="0"/>
+              <a:t> </a:t>
+            </a:r>
+            <a:r>
+              <a:rPr lang="en-US" dirty="0" err="1"/>
+              <a:t>wspólne</a:t>
+            </a:r>
+            <a:r>
+              <a:rPr lang="en-US" dirty="0"/>
+              <a:t> </a:t>
+            </a:r>
+            <a:r>
+              <a:rPr lang="en-US" dirty="0" err="1"/>
+              <a:t>warianty</a:t>
+            </a:r>
+            <a:r>
+              <a:rPr lang="en-US" dirty="0"/>
+              <a:t> </a:t>
+            </a:r>
+            <a:r>
+              <a:rPr lang="en-US" dirty="0" err="1"/>
+              <a:t>kulturowe</a:t>
+            </a:r>
+            <a:r>
+              <a:rPr lang="en-US" dirty="0"/>
+              <a:t> </a:t>
+            </a:r>
+            <a:r>
               <a:rPr lang="en-US" b="1" dirty="0" err="1"/>
-              <a:t>Prawdopodobieństwo</a:t>
+              <a:t>rozprzestrzeniają</a:t>
             </a:r>
             <a:r>
               <a:rPr lang="en-US" b="1" dirty="0"/>
@@ -3874,167 +5373,55 @@
             </a:r>
             <a:r>
               <a:rPr lang="en-US" b="1" dirty="0" err="1"/>
-              <a:t>interakcji</a:t>
-            </a:r>
-            <a:r>
-              <a:rPr lang="en-US" dirty="0"/>
-              <a:t>: </a:t>
-            </a:r>
-            <a:r>
-              <a:rPr lang="en-US" dirty="0" err="1"/>
-              <a:t>agenci</a:t>
-            </a:r>
-            <a:r>
-              <a:rPr lang="en-US" dirty="0"/>
-              <a:t> </a:t>
-            </a:r>
-            <a:r>
-              <a:rPr lang="en-US" dirty="0" err="1"/>
-              <a:t>wejdą</a:t>
-            </a:r>
-            <a:r>
-              <a:rPr lang="en-US" dirty="0"/>
-              <a:t> w </a:t>
-            </a:r>
-            <a:r>
-              <a:rPr lang="en-US" dirty="0" err="1"/>
-              <a:t>interakcję</a:t>
-            </a:r>
-            <a:r>
-              <a:rPr lang="en-US" dirty="0"/>
-              <a:t> w </a:t>
-            </a:r>
-            <a:r>
-              <a:rPr lang="en-US" dirty="0" err="1"/>
-              <a:t>zależności</a:t>
-            </a:r>
-            <a:r>
-              <a:rPr lang="en-US" dirty="0"/>
-              <a:t> </a:t>
-            </a:r>
-            <a:r>
-              <a:rPr lang="pl-PL" dirty="0"/>
-              <a:t> </a:t>
-            </a:r>
-            <a:r>
-              <a:rPr lang="en-US" dirty="0"/>
-              <a:t>od </a:t>
-            </a:r>
-            <a:r>
-              <a:rPr lang="en-US" dirty="0" err="1"/>
-              <a:t>aktualnego</a:t>
-            </a:r>
-            <a:r>
-              <a:rPr lang="en-US" dirty="0"/>
-              <a:t> </a:t>
-            </a:r>
-            <a:r>
-              <a:rPr lang="en-US" dirty="0" err="1"/>
-              <a:t>podobieństwa</a:t>
-            </a:r>
-            <a:r>
-              <a:rPr lang="en-US" dirty="0"/>
-              <a:t> </a:t>
-            </a:r>
-            <a:r>
-              <a:rPr lang="en-US" dirty="0" err="1"/>
-              <a:t>kulturowego</a:t>
-            </a:r>
-            <a:r>
-              <a:rPr lang="en-US" dirty="0"/>
-              <a:t> (np. </a:t>
-            </a:r>
-            <a:r>
-              <a:rPr lang="en-US" dirty="0" err="1"/>
-              <a:t>dla</a:t>
-            </a:r>
-            <a:r>
-              <a:rPr lang="en-US" dirty="0"/>
-              <a:t> 3 </a:t>
-            </a:r>
-            <a:r>
-              <a:rPr lang="en-US" dirty="0" err="1"/>
-              <a:t>cech</a:t>
-            </a:r>
-            <a:r>
-              <a:rPr lang="en-US" dirty="0"/>
-              <a:t> </a:t>
-            </a:r>
-            <a:r>
-              <a:rPr lang="en-US" dirty="0" err="1"/>
-              <a:t>wspólnych</a:t>
-            </a:r>
-            <a:r>
-              <a:rPr lang="en-US" dirty="0"/>
-              <a:t> </a:t>
-            </a:r>
-            <a:r>
-              <a:rPr lang="en-US" dirty="0" err="1"/>
+              <a:t>się</a:t>
+            </a:r>
+            <a:r>
+              <a:rPr lang="en-US" b="1" dirty="0"/>
+              <a:t> </a:t>
+            </a:r>
+            <a:r>
+              <a:rPr lang="en-US" b="1" dirty="0" err="1"/>
               <a:t>na</a:t>
             </a:r>
             <a:r>
-              <a:rPr lang="en-US" dirty="0"/>
-              <a:t> 5 </a:t>
-            </a:r>
-            <a:r>
-              <a:rPr lang="en-US" dirty="0" err="1"/>
-              <a:t>prawdopodobieństwo</a:t>
-            </a:r>
-            <a:r>
-              <a:rPr lang="en-US" dirty="0"/>
-              <a:t> </a:t>
-            </a:r>
-            <a:r>
-              <a:rPr lang="en-US" dirty="0" err="1"/>
-              <a:t>wynosi</a:t>
-            </a:r>
-            <a:r>
-              <a:rPr lang="en-US" dirty="0"/>
-              <a:t> 60\%, a </a:t>
-            </a:r>
-            <a:r>
-              <a:rPr lang="en-US" dirty="0" err="1"/>
-              <a:t>gdy</a:t>
-            </a:r>
-            <a:r>
-              <a:rPr lang="en-US" dirty="0"/>
-              <a:t> </a:t>
-            </a:r>
-            <a:r>
-              <a:rPr lang="en-US" dirty="0" err="1"/>
-              <a:t>brak</a:t>
-            </a:r>
-            <a:r>
-              <a:rPr lang="en-US" dirty="0"/>
-              <a:t> </a:t>
-            </a:r>
-            <a:r>
-              <a:rPr lang="en-US" dirty="0" err="1"/>
-              <a:t>wspólnych</a:t>
-            </a:r>
-            <a:r>
-              <a:rPr lang="en-US" dirty="0"/>
-              <a:t> to </a:t>
-            </a:r>
-            <a:r>
-              <a:rPr lang="en-US" dirty="0" err="1"/>
-              <a:t>nie</a:t>
-            </a:r>
-            <a:r>
-              <a:rPr lang="en-US" dirty="0"/>
-              <a:t> </a:t>
-            </a:r>
-            <a:r>
-              <a:rPr lang="en-US" dirty="0" err="1"/>
-              <a:t>dochodzi</a:t>
-            </a:r>
-            <a:r>
-              <a:rPr lang="en-US" dirty="0"/>
-              <a:t> do </a:t>
-            </a:r>
-            <a:r>
-              <a:rPr lang="en-US" dirty="0" err="1"/>
-              <a:t>interakcji</a:t>
+              <a:rPr lang="en-US" b="1" dirty="0"/>
+              <a:t> </a:t>
+            </a:r>
+            <a:r>
+              <a:rPr lang="en-US" b="1" dirty="0" err="1"/>
+              <a:t>coraz</a:t>
+            </a:r>
+            <a:r>
+              <a:rPr lang="en-US" b="1" dirty="0"/>
+              <a:t> </a:t>
+            </a:r>
+            <a:r>
+              <a:rPr lang="en-US" b="1" dirty="0" err="1"/>
+              <a:t>większe</a:t>
+            </a:r>
+            <a:r>
+              <a:rPr lang="en-US" b="1" dirty="0"/>
+              <a:t> </a:t>
+            </a:r>
+            <a:r>
+              <a:rPr lang="en-US" b="1" dirty="0" err="1"/>
+              <a:t>obszary</a:t>
+            </a:r>
+            <a:r>
+              <a:rPr lang="en-US" dirty="0"/>
+              <a:t> (</a:t>
+            </a:r>
+            <a:r>
+              <a:rPr lang="en-US" dirty="0" err="1"/>
+              <a:t>regiony</a:t>
+            </a:r>
+            <a:r>
+              <a:rPr lang="en-US" dirty="0"/>
+              <a:t> </a:t>
+            </a:r>
+            <a:r>
+              <a:rPr lang="en-US" dirty="0" err="1"/>
+              <a:t>kulturowe</a:t>
             </a:r>
             <a:r>
               <a:rPr lang="en-US" dirty="0"/>
@@ -4047,60 +5434,52 @@
               <a:buAutoNum type="arabicPeriod"/>
             </a:pPr>
             <a:r>
+              <a:rPr lang="en-US" b="1" dirty="0"/>
+              <a:t>Stan </a:t>
+            </a:r>
+            <a:r>
               <a:rPr lang="en-US" b="1" dirty="0" err="1"/>
-              <a:t>Modyfikacja</a:t>
-            </a:r>
-            <a:r>
-              <a:rPr lang="en-US" b="1" dirty="0"/>
-              <a:t> </a:t>
-            </a:r>
-            <a:r>
-              <a:rPr lang="en-US" b="1" dirty="0" err="1"/>
-              <a:t>cechy</a:t>
+              <a:t>stacjonarny</a:t>
             </a:r>
             <a:r>
               <a:rPr lang="en-US" b="1" dirty="0"/>
               <a:t>: </a:t>
             </a:r>
             <a:r>
-              <a:rPr lang="en-US" dirty="0"/>
-              <a:t>agent </a:t>
-            </a:r>
-            <a:r>
-              <a:rPr lang="en-US" dirty="0" err="1"/>
-              <a:t>losowo</a:t>
-            </a:r>
-            <a:r>
-              <a:rPr lang="en-US" dirty="0"/>
-              <a:t> </a:t>
-            </a:r>
-            <a:r>
-              <a:rPr lang="en-US" dirty="0" err="1"/>
-              <a:t>przyjmuje</a:t>
-            </a:r>
-            <a:r>
-              <a:rPr lang="en-US" dirty="0"/>
-              <a:t> </a:t>
-            </a:r>
-            <a:r>
-              <a:rPr lang="en-US" dirty="0" err="1"/>
-              <a:t>jedną</a:t>
-            </a:r>
-            <a:r>
-              <a:rPr lang="en-US" dirty="0"/>
-              <a:t> </a:t>
-            </a:r>
-            <a:r>
-              <a:rPr lang="en-US" dirty="0" err="1"/>
-              <a:t>cechę</a:t>
-            </a:r>
-            <a:r>
-              <a:rPr lang="en-US" dirty="0"/>
-              <a:t> </a:t>
-            </a:r>
-            <a:r>
-              <a:rPr lang="en-US" dirty="0" err="1"/>
-              <a:t>sąsiada</a:t>
+              <a:rPr lang="en-US" dirty="0" err="1"/>
+              <a:t>proces</a:t>
+            </a:r>
+            <a:r>
+              <a:rPr lang="en-US" dirty="0"/>
+              <a:t> </a:t>
+            </a:r>
+            <a:r>
+              <a:rPr lang="en-US" dirty="0" err="1"/>
+              <a:t>kończy</a:t>
+            </a:r>
+            <a:r>
+              <a:rPr lang="en-US" dirty="0"/>
+              <a:t> </a:t>
+            </a:r>
+            <a:r>
+              <a:rPr lang="en-US" dirty="0" err="1"/>
+              <a:t>się</a:t>
+            </a:r>
+            <a:r>
+              <a:rPr lang="en-US" dirty="0"/>
+              <a:t> </a:t>
+            </a:r>
+            <a:r>
+              <a:rPr lang="en-US" dirty="0" err="1"/>
+              <a:t>i</a:t>
+            </a:r>
+            <a:r>
+              <a:rPr lang="en-US" dirty="0"/>
+              <a:t> </a:t>
+            </a:r>
+            <a:r>
+              <a:rPr lang="en-US" dirty="0" err="1"/>
+              <a:t>stabilizuje</a:t>
             </a:r>
             <a:r>
               <a:rPr lang="en-US" dirty="0"/>
@@ -4108,648 +5487,130 @@
             </a:r>
             <a:r>
               <a:rPr lang="en-US" dirty="0" err="1"/>
-              <a:t>czyli</a:t>
-            </a:r>
-            <a:r>
-              <a:rPr lang="en-US" dirty="0"/>
-              <a:t> </a:t>
-            </a:r>
-            <a:r>
-              <a:rPr lang="en-US" dirty="0" err="1"/>
-              <a:t>zwiększa</a:t>
-            </a:r>
-            <a:r>
-              <a:rPr lang="en-US" dirty="0"/>
-              <a:t> </a:t>
-            </a:r>
-            <a:r>
-              <a:rPr lang="en-US" dirty="0" err="1"/>
-              <a:t>podobieństwo</a:t>
-            </a:r>
-            <a:r>
-              <a:rPr lang="en-US" dirty="0"/>
-              <a:t> </a:t>
-            </a:r>
-            <a:r>
-              <a:rPr lang="en-US" dirty="0" err="1"/>
-              <a:t>kulturowe</a:t>
-            </a:r>
-            <a:r>
-              <a:rPr lang="en-US" dirty="0"/>
-              <a:t>.</a:t>
-            </a:r>
-          </a:p>
-          <a:p>
-            <a:pPr marL="0" indent="0">
-              <a:buNone/>
-            </a:pPr>
-            <a:endParaRPr lang="en-US" dirty="0"/>
+              <a:t>gdy</a:t>
+            </a:r>
+            <a:r>
+              <a:rPr lang="en-US" dirty="0"/>
+              <a:t> </a:t>
+            </a:r>
+            <a:r>
+              <a:rPr lang="en-US" dirty="0" err="1"/>
+              <a:t>żadna</a:t>
+            </a:r>
+            <a:r>
+              <a:rPr lang="en-US" dirty="0"/>
+              <a:t> para </a:t>
+            </a:r>
+            <a:r>
+              <a:rPr lang="en-US" dirty="0" err="1"/>
+              <a:t>sąsiadujących</a:t>
+            </a:r>
+            <a:r>
+              <a:rPr lang="en-US" dirty="0"/>
+              <a:t> </a:t>
+            </a:r>
+            <a:r>
+              <a:rPr lang="en-US" dirty="0" err="1"/>
+              <a:t>jednostek</a:t>
+            </a:r>
+            <a:r>
+              <a:rPr lang="en-US" dirty="0"/>
+              <a:t>  </a:t>
+            </a:r>
+            <a:r>
+              <a:rPr lang="en-US" dirty="0" err="1"/>
+              <a:t>nie</a:t>
+            </a:r>
+            <a:r>
+              <a:rPr lang="en-US" dirty="0"/>
+              <a:t> </a:t>
+            </a:r>
+            <a:r>
+              <a:rPr lang="en-US" dirty="0" err="1"/>
+              <a:t>może</a:t>
+            </a:r>
+            <a:r>
+              <a:rPr lang="en-US" dirty="0"/>
+              <a:t> </a:t>
+            </a:r>
+            <a:r>
+              <a:rPr lang="en-US" dirty="0" err="1"/>
+              <a:t>już</a:t>
+            </a:r>
+            <a:r>
+              <a:rPr lang="en-US" dirty="0"/>
+              <a:t> </a:t>
+            </a:r>
+            <a:r>
+              <a:rPr lang="en-US" dirty="0" err="1"/>
+              <a:t>zmienić</a:t>
+            </a:r>
+            <a:r>
+              <a:rPr lang="en-US" dirty="0"/>
+              <a:t> </a:t>
+            </a:r>
+            <a:r>
+              <a:rPr lang="en-US" dirty="0" err="1"/>
+              <a:t>swojej</a:t>
+            </a:r>
+            <a:r>
+              <a:rPr lang="en-US" dirty="0"/>
+              <a:t> </a:t>
+            </a:r>
+            <a:r>
+              <a:rPr lang="en-US" dirty="0" err="1"/>
+              <a:t>kultury</a:t>
+            </a:r>
+            <a:r>
+              <a:rPr lang="en-US" dirty="0"/>
+              <a:t> (</a:t>
+            </a:r>
+            <a:r>
+              <a:rPr lang="en-US" dirty="0" err="1"/>
+              <a:t>całkowicie</a:t>
+            </a:r>
+            <a:r>
+              <a:rPr lang="en-US" dirty="0"/>
+              <a:t> </a:t>
+            </a:r>
+            <a:r>
+              <a:rPr lang="en-US" dirty="0" err="1"/>
+              <a:t>identyczni</a:t>
+            </a:r>
+            <a:r>
+              <a:rPr lang="en-US" dirty="0"/>
+              <a:t> </a:t>
+            </a:r>
+            <a:r>
+              <a:rPr lang="en-US" dirty="0" err="1"/>
+              <a:t>albo</a:t>
+            </a:r>
+            <a:r>
+              <a:rPr lang="en-US" dirty="0"/>
+              <a:t> </a:t>
+            </a:r>
+            <a:r>
+              <a:rPr lang="en-US" dirty="0" err="1"/>
+              <a:t>całkowicie</a:t>
+            </a:r>
+            <a:r>
+              <a:rPr lang="en-US" dirty="0"/>
+              <a:t> </a:t>
+            </a:r>
+            <a:r>
+              <a:rPr lang="en-US" dirty="0" err="1"/>
+              <a:t>odmienni</a:t>
+            </a:r>
+            <a:r>
+              <a:rPr lang="en-US" dirty="0"/>
+              <a:t>).</a:t>
+            </a:r>
           </a:p>
           <a:p>
             <a:pPr marL="514350" indent="-514350">
               <a:buFont typeface="+mj-lt"/>
               <a:buAutoNum type="arabicPeriod"/>
             </a:pPr>
-            <a:endParaRPr lang="en-US" dirty="0"/>
-          </a:p>
-        </p:txBody>
-      </p:sp>
-    </p:spTree>
-    <p:extLst>
-      <p:ext uri="{BB962C8B-B14F-4D97-AF65-F5344CB8AC3E}">
-        <p14:creationId xmlns:p14="http://schemas.microsoft.com/office/powerpoint/2010/main" val="3379100194"/>
-      </p:ext>
-    </p:extLst>
-  </p:cSld>
-  <p:clrMapOvr>
-    <a:masterClrMapping/>
-  </p:clrMapOvr>
-</p:sld>
-</file>
-
-<file path=ppt/slides/slide5.xml><?xml version="1.0" encoding="utf-8"?>
-<p:sld xmlns:a="http://schemas.openxmlformats.org/drawingml/2006/main" xmlns:r="http://schemas.openxmlformats.org/officeDocument/2006/relationships" xmlns:p="http://schemas.openxmlformats.org/presentationml/2006/main">
-  <p:cSld>
-    <p:spTree>
-      <p:nvGrpSpPr>
-        <p:cNvPr id="1" name=""/>
-        <p:cNvGrpSpPr/>
-        <p:nvPr/>
-      </p:nvGrpSpPr>
-      <p:grpSpPr>
-        <a:xfrm>
-          <a:off x="0" y="0"/>
-          <a:ext cx="0" cy="0"/>
-          <a:chOff x="0" y="0"/>
-          <a:chExt cx="0" cy="0"/>
-        </a:xfrm>
-      </p:grpSpPr>
-      <p:sp>
-        <p:nvSpPr>
-          <p:cNvPr id="2" name="Tytuł 1">
-            <a:extLst>
-              <a:ext uri="{FF2B5EF4-FFF2-40B4-BE49-F238E27FC236}">
-                <a16:creationId xmlns:a16="http://schemas.microsoft.com/office/drawing/2014/main" id="{B66288A7-C2FF-EEAF-913F-879F9A76983E}"/>
-              </a:ext>
-            </a:extLst>
-          </p:cNvPr>
-          <p:cNvSpPr>
-            <a:spLocks noGrp="1"/>
-          </p:cNvSpPr>
-          <p:nvPr>
-            <p:ph type="title"/>
-          </p:nvPr>
-        </p:nvSpPr>
-        <p:spPr/>
-        <p:txBody>
-          <a:bodyPr/>
-          <a:lstStyle/>
-          <a:p>
-            <a:r>
-              <a:rPr lang="en-US" dirty="0" err="1"/>
-              <a:t>Przebieg</a:t>
-            </a:r>
-            <a:r>
-              <a:rPr lang="en-US" dirty="0"/>
-              <a:t> </a:t>
-            </a:r>
-            <a:r>
-              <a:rPr lang="en-US" dirty="0" err="1"/>
-              <a:t>symulacji</a:t>
-            </a:r>
-            <a:endParaRPr lang="en-US" dirty="0"/>
-          </a:p>
-        </p:txBody>
-      </p:sp>
-      <p:sp>
-        <p:nvSpPr>
-          <p:cNvPr id="3" name="Symbol zastępczy zawartości 2">
-            <a:extLst>
-              <a:ext uri="{FF2B5EF4-FFF2-40B4-BE49-F238E27FC236}">
-                <a16:creationId xmlns:a16="http://schemas.microsoft.com/office/drawing/2014/main" id="{0F17B2F8-4EF7-6C2B-E34A-76E8DFB21229}"/>
-              </a:ext>
-            </a:extLst>
-          </p:cNvPr>
-          <p:cNvSpPr>
-            <a:spLocks noGrp="1"/>
-          </p:cNvSpPr>
-          <p:nvPr>
-            <p:ph idx="1"/>
-          </p:nvPr>
-        </p:nvSpPr>
-        <p:spPr/>
-        <p:txBody>
-          <a:bodyPr>
-            <a:normAutofit fontScale="92500" lnSpcReduction="10000"/>
-          </a:bodyPr>
-          <a:lstStyle/>
-          <a:p>
-            <a:pPr marL="514350" indent="-514350">
-              <a:buFont typeface="+mj-lt"/>
-              <a:buAutoNum type="arabicPeriod"/>
-            </a:pPr>
-            <a:r>
-              <a:rPr lang="en-US" dirty="0"/>
-              <a:t>Na </a:t>
-            </a:r>
-            <a:r>
-              <a:rPr lang="en-US" dirty="0" err="1"/>
-              <a:t>początku</a:t>
-            </a:r>
-            <a:r>
-              <a:rPr lang="en-US" dirty="0"/>
-              <a:t> </a:t>
-            </a:r>
-            <a:r>
-              <a:rPr lang="en-US" dirty="0" err="1"/>
-              <a:t>agenci</a:t>
-            </a:r>
-            <a:r>
-              <a:rPr lang="en-US" dirty="0"/>
-              <a:t> </a:t>
-            </a:r>
-            <a:r>
-              <a:rPr lang="en-US" dirty="0" err="1"/>
-              <a:t>mają</a:t>
-            </a:r>
-            <a:r>
-              <a:rPr lang="en-US" dirty="0"/>
-              <a:t> </a:t>
-            </a:r>
-            <a:r>
-              <a:rPr lang="en-US" dirty="0" err="1"/>
-              <a:t>losowo</a:t>
-            </a:r>
-            <a:r>
-              <a:rPr lang="en-US" dirty="0"/>
-              <a:t> </a:t>
-            </a:r>
-            <a:r>
-              <a:rPr lang="en-US" dirty="0" err="1"/>
-              <a:t>przypisane</a:t>
-            </a:r>
-            <a:r>
-              <a:rPr lang="en-US" dirty="0"/>
-              <a:t> </a:t>
-            </a:r>
-            <a:r>
-              <a:rPr lang="en-US" dirty="0" err="1"/>
-              <a:t>warianty</a:t>
-            </a:r>
-            <a:r>
-              <a:rPr lang="en-US" dirty="0"/>
-              <a:t> </a:t>
-            </a:r>
-            <a:r>
-              <a:rPr lang="en-US" dirty="0" err="1"/>
-              <a:t>kulturowe</a:t>
-            </a:r>
-            <a:r>
-              <a:rPr lang="en-US" dirty="0"/>
-              <a:t>. </a:t>
-            </a:r>
-            <a:r>
-              <a:rPr lang="en-US" dirty="0" err="1"/>
-              <a:t>Większość</a:t>
-            </a:r>
-            <a:r>
-              <a:rPr lang="en-US" dirty="0"/>
-              <a:t> </a:t>
-            </a:r>
-            <a:r>
-              <a:rPr lang="en-US" dirty="0" err="1"/>
-              <a:t>sąsiadów</a:t>
-            </a:r>
-            <a:r>
-              <a:rPr lang="en-US" dirty="0"/>
-              <a:t> ma ze </a:t>
-            </a:r>
-            <a:r>
-              <a:rPr lang="en-US" dirty="0" err="1"/>
-              <a:t>sobą</a:t>
-            </a:r>
-            <a:r>
-              <a:rPr lang="en-US" dirty="0"/>
-              <a:t> </a:t>
-            </a:r>
-            <a:r>
-              <a:rPr lang="en-US" b="1" dirty="0" err="1"/>
-              <a:t>bardzo</a:t>
-            </a:r>
-            <a:r>
-              <a:rPr lang="en-US" b="1" dirty="0"/>
-              <a:t> </a:t>
-            </a:r>
-            <a:r>
-              <a:rPr lang="en-US" b="1" dirty="0" err="1"/>
-              <a:t>mało</a:t>
-            </a:r>
-            <a:r>
-              <a:rPr lang="en-US" b="1" dirty="0"/>
-              <a:t> </a:t>
-            </a:r>
-            <a:r>
-              <a:rPr lang="en-US" b="1" dirty="0" err="1"/>
-              <a:t>wspólnego</a:t>
-            </a:r>
-            <a:r>
-              <a:rPr lang="en-US" b="1" dirty="0"/>
-              <a:t> </a:t>
-            </a:r>
-            <a:r>
-              <a:rPr lang="en-US" dirty="0"/>
-              <a:t>(</a:t>
-            </a:r>
-            <a:r>
-              <a:rPr lang="en-US" dirty="0" err="1"/>
-              <a:t>dużo</a:t>
-            </a:r>
-            <a:r>
-              <a:rPr lang="en-US" dirty="0"/>
-              <a:t> </a:t>
-            </a:r>
-            <a:r>
-              <a:rPr lang="en-US" dirty="0" err="1"/>
-              <a:t>różnych</a:t>
-            </a:r>
-            <a:r>
-              <a:rPr lang="en-US" dirty="0"/>
-              <a:t> </a:t>
-            </a:r>
-            <a:r>
-              <a:rPr lang="en-US" dirty="0" err="1"/>
-              <a:t>kolorów</a:t>
-            </a:r>
-            <a:r>
-              <a:rPr lang="en-US" dirty="0"/>
-              <a:t> </a:t>
-            </a:r>
-            <a:r>
-              <a:rPr lang="en-US" dirty="0" err="1"/>
-              <a:t>na</a:t>
-            </a:r>
-            <a:r>
-              <a:rPr lang="en-US" dirty="0"/>
-              <a:t> </a:t>
-            </a:r>
-            <a:r>
-              <a:rPr lang="pl-PL" dirty="0"/>
-              <a:t>następnym slajdzie</a:t>
-            </a:r>
-            <a:r>
-              <a:rPr lang="en-US" dirty="0"/>
-              <a:t>).</a:t>
-            </a:r>
-          </a:p>
-          <a:p>
-            <a:pPr marL="514350" indent="-514350">
-              <a:buFont typeface="+mj-lt"/>
-              <a:buAutoNum type="arabicPeriod"/>
-            </a:pPr>
-            <a:r>
-              <a:rPr lang="en-US" dirty="0"/>
-              <a:t>      W </a:t>
-            </a:r>
-            <a:r>
-              <a:rPr lang="en-US" dirty="0" err="1"/>
-              <a:t>miarę</a:t>
-            </a:r>
-            <a:r>
-              <a:rPr lang="en-US" dirty="0"/>
-              <a:t> </a:t>
-            </a:r>
-            <a:r>
-              <a:rPr lang="en-US" dirty="0" err="1"/>
-              <a:t>upływu</a:t>
-            </a:r>
-            <a:r>
-              <a:rPr lang="en-US" dirty="0"/>
-              <a:t> </a:t>
-            </a:r>
-            <a:r>
-              <a:rPr lang="en-US" dirty="0" err="1"/>
-              <a:t>czasu</a:t>
-            </a:r>
-            <a:r>
-              <a:rPr lang="en-US" dirty="0"/>
-              <a:t> (</a:t>
-            </a:r>
-            <a:r>
-              <a:rPr lang="en-US" dirty="0" err="1"/>
-              <a:t>zdarzeń</a:t>
-            </a:r>
-            <a:r>
-              <a:rPr lang="en-US" dirty="0"/>
-              <a:t>) </a:t>
-            </a:r>
-            <a:r>
-              <a:rPr lang="en-US" dirty="0" err="1"/>
-              <a:t>lokalne</a:t>
-            </a:r>
-            <a:r>
-              <a:rPr lang="en-US" dirty="0"/>
-              <a:t> </a:t>
-            </a:r>
-            <a:r>
-              <a:rPr lang="en-US" dirty="0" err="1"/>
-              <a:t>interakcje</a:t>
-            </a:r>
-            <a:r>
-              <a:rPr lang="en-US" dirty="0"/>
-              <a:t> </a:t>
-            </a:r>
-            <a:r>
-              <a:rPr lang="en-US" dirty="0" err="1"/>
-              <a:t>powodują</a:t>
-            </a:r>
-            <a:r>
-              <a:rPr lang="en-US" dirty="0"/>
-              <a:t>, </a:t>
-            </a:r>
-            <a:r>
-              <a:rPr lang="en-US" dirty="0" err="1"/>
-              <a:t>że</a:t>
-            </a:r>
-            <a:r>
-              <a:rPr lang="en-US" dirty="0"/>
-              <a:t> </a:t>
-            </a:r>
-            <a:r>
-              <a:rPr lang="en-US" dirty="0" err="1"/>
-              <a:t>wspólne</a:t>
-            </a:r>
-            <a:r>
-              <a:rPr lang="en-US" dirty="0"/>
-              <a:t> </a:t>
-            </a:r>
-            <a:r>
-              <a:rPr lang="en-US" dirty="0" err="1"/>
-              <a:t>warianty</a:t>
-            </a:r>
-            <a:r>
-              <a:rPr lang="en-US" dirty="0"/>
-              <a:t> </a:t>
-            </a:r>
-            <a:r>
-              <a:rPr lang="en-US" dirty="0" err="1"/>
-              <a:t>kulturowe</a:t>
-            </a:r>
-            <a:r>
-              <a:rPr lang="en-US" dirty="0"/>
-              <a:t> </a:t>
-            </a:r>
-            <a:r>
-              <a:rPr lang="en-US" b="1" dirty="0" err="1"/>
-              <a:t>rozprzestrzeniają</a:t>
-            </a:r>
-            <a:r>
-              <a:rPr lang="en-US" b="1" dirty="0"/>
-              <a:t> </a:t>
-            </a:r>
-            <a:r>
-              <a:rPr lang="en-US" b="1" dirty="0" err="1"/>
-              <a:t>się</a:t>
-            </a:r>
-            <a:r>
-              <a:rPr lang="en-US" b="1" dirty="0"/>
-              <a:t> </a:t>
-            </a:r>
-            <a:r>
-              <a:rPr lang="en-US" b="1" dirty="0" err="1"/>
-              <a:t>na</a:t>
-            </a:r>
-            <a:r>
-              <a:rPr lang="en-US" b="1" dirty="0"/>
-              <a:t> </a:t>
-            </a:r>
-            <a:r>
-              <a:rPr lang="en-US" b="1" dirty="0" err="1"/>
-              <a:t>coraz</a:t>
-            </a:r>
-            <a:r>
-              <a:rPr lang="en-US" b="1" dirty="0"/>
-              <a:t> </a:t>
-            </a:r>
-            <a:r>
-              <a:rPr lang="en-US" b="1" dirty="0" err="1"/>
-              <a:t>większe</a:t>
-            </a:r>
-            <a:r>
-              <a:rPr lang="en-US" b="1" dirty="0"/>
-              <a:t> </a:t>
-            </a:r>
-            <a:r>
-              <a:rPr lang="en-US" b="1" dirty="0" err="1"/>
-              <a:t>obszary</a:t>
-            </a:r>
-            <a:r>
-              <a:rPr lang="en-US" dirty="0"/>
-              <a:t> (</a:t>
-            </a:r>
-            <a:r>
-              <a:rPr lang="en-US" dirty="0" err="1"/>
-              <a:t>regiony</a:t>
-            </a:r>
-            <a:r>
-              <a:rPr lang="en-US" dirty="0"/>
-              <a:t> </a:t>
-            </a:r>
-            <a:r>
-              <a:rPr lang="en-US" dirty="0" err="1"/>
-              <a:t>kulturowe</a:t>
-            </a:r>
-            <a:r>
-              <a:rPr lang="en-US" dirty="0"/>
-              <a:t>).</a:t>
-            </a:r>
-          </a:p>
-          <a:p>
-            <a:pPr marL="514350" indent="-514350">
-              <a:buFont typeface="+mj-lt"/>
-              <a:buAutoNum type="arabicPeriod"/>
-            </a:pPr>
-            <a:r>
-              <a:rPr lang="en-US" b="1" dirty="0"/>
-              <a:t>      Stan </a:t>
-            </a:r>
-            <a:r>
-              <a:rPr lang="en-US" b="1" dirty="0" err="1"/>
-              <a:t>stacjonarny</a:t>
-            </a:r>
-            <a:r>
-              <a:rPr lang="en-US" b="1" dirty="0"/>
-              <a:t>: </a:t>
-            </a:r>
-            <a:r>
-              <a:rPr lang="en-US" dirty="0" err="1"/>
-              <a:t>proces</a:t>
-            </a:r>
-            <a:r>
-              <a:rPr lang="en-US" dirty="0"/>
-              <a:t> </a:t>
-            </a:r>
-            <a:r>
-              <a:rPr lang="en-US" dirty="0" err="1"/>
-              <a:t>kończy</a:t>
-            </a:r>
-            <a:r>
-              <a:rPr lang="en-US" dirty="0"/>
-              <a:t> </a:t>
-            </a:r>
-            <a:r>
-              <a:rPr lang="en-US" dirty="0" err="1"/>
-              <a:t>się</a:t>
-            </a:r>
-            <a:r>
-              <a:rPr lang="en-US" dirty="0"/>
-              <a:t> </a:t>
-            </a:r>
-            <a:r>
-              <a:rPr lang="en-US" dirty="0" err="1"/>
-              <a:t>i</a:t>
-            </a:r>
-            <a:r>
-              <a:rPr lang="en-US" dirty="0"/>
-              <a:t> </a:t>
-            </a:r>
-            <a:r>
-              <a:rPr lang="en-US" dirty="0" err="1"/>
-              <a:t>stabilizuje</a:t>
-            </a:r>
-            <a:r>
-              <a:rPr lang="en-US" dirty="0"/>
-              <a:t>, </a:t>
-            </a:r>
-            <a:r>
-              <a:rPr lang="en-US" dirty="0" err="1"/>
-              <a:t>gdy</a:t>
-            </a:r>
-            <a:r>
-              <a:rPr lang="en-US" dirty="0"/>
-              <a:t> </a:t>
-            </a:r>
-            <a:r>
-              <a:rPr lang="en-US" dirty="0" err="1"/>
-              <a:t>żadna</a:t>
-            </a:r>
-            <a:r>
-              <a:rPr lang="en-US" dirty="0"/>
-              <a:t> para </a:t>
-            </a:r>
-            <a:r>
-              <a:rPr lang="en-US" dirty="0" err="1"/>
-              <a:t>sąsiadujących</a:t>
-            </a:r>
-            <a:r>
-              <a:rPr lang="en-US" dirty="0"/>
-              <a:t> </a:t>
-            </a:r>
-            <a:r>
-              <a:rPr lang="en-US" dirty="0" err="1"/>
-              <a:t>jednostek</a:t>
-            </a:r>
-            <a:r>
-              <a:rPr lang="en-US" dirty="0"/>
-              <a:t>  </a:t>
-            </a:r>
-            <a:r>
-              <a:rPr lang="en-US" dirty="0" err="1"/>
-              <a:t>nie</a:t>
-            </a:r>
-            <a:r>
-              <a:rPr lang="en-US" dirty="0"/>
-              <a:t> </a:t>
-            </a:r>
-            <a:r>
-              <a:rPr lang="en-US" dirty="0" err="1"/>
-              <a:t>może</a:t>
-            </a:r>
-            <a:r>
-              <a:rPr lang="en-US" dirty="0"/>
-              <a:t> </a:t>
-            </a:r>
-            <a:r>
-              <a:rPr lang="en-US" dirty="0" err="1"/>
-              <a:t>już</a:t>
-            </a:r>
-            <a:r>
-              <a:rPr lang="en-US" dirty="0"/>
-              <a:t> </a:t>
-            </a:r>
-            <a:r>
-              <a:rPr lang="en-US" dirty="0" err="1"/>
-              <a:t>zmienić</a:t>
-            </a:r>
-            <a:r>
-              <a:rPr lang="en-US" dirty="0"/>
-              <a:t> </a:t>
-            </a:r>
-            <a:r>
-              <a:rPr lang="en-US" dirty="0" err="1"/>
-              <a:t>swojej</a:t>
-            </a:r>
-            <a:r>
-              <a:rPr lang="en-US" dirty="0"/>
-              <a:t> </a:t>
-            </a:r>
-            <a:r>
-              <a:rPr lang="en-US" dirty="0" err="1"/>
-              <a:t>kultury</a:t>
-            </a:r>
-            <a:r>
-              <a:rPr lang="en-US" dirty="0"/>
-              <a:t> (</a:t>
-            </a:r>
-            <a:r>
-              <a:rPr lang="en-US" dirty="0" err="1"/>
-              <a:t>całkowicie</a:t>
-            </a:r>
-            <a:r>
-              <a:rPr lang="en-US" dirty="0"/>
-              <a:t> </a:t>
-            </a:r>
-            <a:r>
-              <a:rPr lang="en-US" dirty="0" err="1"/>
-              <a:t>identyczni</a:t>
-            </a:r>
-            <a:r>
-              <a:rPr lang="en-US" dirty="0"/>
-              <a:t> </a:t>
-            </a:r>
-            <a:r>
-              <a:rPr lang="en-US" dirty="0" err="1"/>
-              <a:t>albo</a:t>
-            </a:r>
-            <a:r>
-              <a:rPr lang="en-US" dirty="0"/>
-              <a:t> </a:t>
-            </a:r>
-            <a:r>
-              <a:rPr lang="en-US" dirty="0" err="1"/>
-              <a:t>całkowicie</a:t>
-            </a:r>
-            <a:r>
-              <a:rPr lang="en-US" dirty="0"/>
-              <a:t> </a:t>
-            </a:r>
-            <a:r>
-              <a:rPr lang="en-US" dirty="0" err="1"/>
-              <a:t>odmienni</a:t>
-            </a:r>
-            <a:r>
-              <a:rPr lang="en-US" dirty="0"/>
-              <a:t>).</a:t>
-            </a:r>
-          </a:p>
-          <a:p>
-            <a:pPr marL="514350" indent="-514350">
-              <a:buFont typeface="+mj-lt"/>
-              <a:buAutoNum type="arabicPeriod"/>
-            </a:pPr>
-            <a:r>
-              <a:rPr lang="en-US" b="1" dirty="0"/>
-              <a:t>        </a:t>
-            </a:r>
             <a:r>
               <a:rPr lang="en-US" b="1" dirty="0" err="1"/>
               <a:t>Wynik</a:t>
@@ -4771,15 +5632,15 @@
               <a:t>to </a:t>
             </a:r>
             <a:r>
-              <a:rPr lang="en-US" dirty="0" err="1"/>
+              <a:rPr lang="en-US" b="1" dirty="0" err="1"/>
               <a:t>globalna</a:t>
             </a:r>
             <a:r>
-              <a:rPr lang="en-US" dirty="0"/>
-              <a:t> </a:t>
-            </a:r>
-            <a:r>
-              <a:rPr lang="en-US" dirty="0" err="1"/>
+              <a:rPr lang="en-US" b="1" dirty="0"/>
+              <a:t> </a:t>
+            </a:r>
+            <a:r>
+              <a:rPr lang="en-US" b="1" dirty="0" err="1"/>
               <a:t>polaryzacja</a:t>
             </a:r>
             <a:r>
@@ -4869,7 +5730,7 @@
 </p:sld>
 </file>
 
-<file path=ppt/slides/slide6.xml><?xml version="1.0" encoding="utf-8"?>
+<file path=ppt/slides/slide5.xml><?xml version="1.0" encoding="utf-8"?>
 <p:sld xmlns:a="http://schemas.openxmlformats.org/drawingml/2006/main" xmlns:r="http://schemas.openxmlformats.org/officeDocument/2006/relationships" xmlns:p="http://schemas.openxmlformats.org/presentationml/2006/main">
   <p:cSld>
     <p:spTree>
@@ -4935,6 +5796,120 @@
 </p:sld>
 </file>
 
+<file path=ppt/slides/slide6.xml><?xml version="1.0" encoding="utf-8"?>
+<p:sld xmlns:a="http://schemas.openxmlformats.org/drawingml/2006/main" xmlns:r="http://schemas.openxmlformats.org/officeDocument/2006/relationships" xmlns:p="http://schemas.openxmlformats.org/presentationml/2006/main">
+  <p:cSld>
+    <p:spTree>
+      <p:nvGrpSpPr>
+        <p:cNvPr id="1" name=""/>
+        <p:cNvGrpSpPr/>
+        <p:nvPr/>
+      </p:nvGrpSpPr>
+      <p:grpSpPr>
+        <a:xfrm>
+          <a:off x="0" y="0"/>
+          <a:ext cx="0" cy="0"/>
+          <a:chOff x="0" y="0"/>
+          <a:chExt cx="0" cy="0"/>
+        </a:xfrm>
+      </p:grpSpPr>
+      <p:sp>
+        <p:nvSpPr>
+          <p:cNvPr id="2" name="Tytuł 1">
+            <a:extLst>
+              <a:ext uri="{FF2B5EF4-FFF2-40B4-BE49-F238E27FC236}">
+                <a16:creationId xmlns:a16="http://schemas.microsoft.com/office/drawing/2014/main" id="{D0B8A69A-FCE4-1153-712A-FAC99C76CCDF}"/>
+              </a:ext>
+            </a:extLst>
+          </p:cNvPr>
+          <p:cNvSpPr>
+            <a:spLocks noGrp="1"/>
+          </p:cNvSpPr>
+          <p:nvPr>
+            <p:ph type="ctrTitle"/>
+          </p:nvPr>
+        </p:nvSpPr>
+        <p:spPr/>
+        <p:txBody>
+          <a:bodyPr/>
+          <a:lstStyle/>
+          <a:p>
+            <a:r>
+              <a:rPr lang="pl-PL" dirty="0"/>
+              <a:t>	TU CALE ZDJECIA I STATYSTYKA </a:t>
+            </a:r>
+            <a:endParaRPr lang="en-US" dirty="0"/>
+          </a:p>
+        </p:txBody>
+      </p:sp>
+      <p:sp>
+        <p:nvSpPr>
+          <p:cNvPr id="3" name="Podtytuł 2">
+            <a:extLst>
+              <a:ext uri="{FF2B5EF4-FFF2-40B4-BE49-F238E27FC236}">
+                <a16:creationId xmlns:a16="http://schemas.microsoft.com/office/drawing/2014/main" id="{53B25650-7C85-A4E5-2F5F-CB2D99D6E4C4}"/>
+              </a:ext>
+            </a:extLst>
+          </p:cNvPr>
+          <p:cNvSpPr>
+            <a:spLocks noGrp="1"/>
+          </p:cNvSpPr>
+          <p:nvPr>
+            <p:ph type="subTitle" idx="1"/>
+          </p:nvPr>
+        </p:nvSpPr>
+        <p:spPr/>
+        <p:txBody>
+          <a:bodyPr>
+            <a:normAutofit fontScale="92500"/>
+          </a:bodyPr>
+          <a:lstStyle/>
+          <a:p>
+            <a:r>
+              <a:rPr lang="pl-PL" sz="7200" dirty="0">
+                <a:highlight>
+                  <a:srgbClr val="FFFF00"/>
+                </a:highlight>
+              </a:rPr>
+              <a:t>DO ZROBIENIA </a:t>
+            </a:r>
+            <a:r>
+              <a:rPr lang="pl-PL" sz="7200" dirty="0" err="1">
+                <a:highlight>
+                  <a:srgbClr val="FFFF00"/>
+                </a:highlight>
+              </a:rPr>
+              <a:t>sZyMoN</a:t>
+            </a:r>
+            <a:r>
+              <a:rPr lang="pl-PL" sz="7200" dirty="0">
+                <a:highlight>
+                  <a:srgbClr val="FFFF00"/>
+                </a:highlight>
+              </a:rPr>
+              <a:t>!</a:t>
+            </a:r>
+            <a:endParaRPr lang="en-US" sz="7200" dirty="0">
+              <a:highlight>
+                <a:srgbClr val="FFFF00"/>
+              </a:highlight>
+            </a:endParaRPr>
+          </a:p>
+        </p:txBody>
+      </p:sp>
+    </p:spTree>
+    <p:extLst>
+      <p:ext uri="{BB962C8B-B14F-4D97-AF65-F5344CB8AC3E}">
+        <p14:creationId xmlns:p14="http://schemas.microsoft.com/office/powerpoint/2010/main" val="3546194582"/>
+      </p:ext>
+    </p:extLst>
+  </p:cSld>
+  <p:clrMapOvr>
+    <a:masterClrMapping/>
+  </p:clrMapOvr>
+</p:sld>
+</file>
+
 <file path=ppt/slides/slide7.xml><?xml version="1.0" encoding="utf-8"?>
 <p:sld xmlns:a="http://schemas.openxmlformats.org/drawingml/2006/main" xmlns:r="http://schemas.openxmlformats.org/officeDocument/2006/relationships" xmlns:p="http://schemas.openxmlformats.org/presentationml/2006/main">
   <p:cSld>
@@ -4957,15 +5932,15 @@
           <p:cNvPr id="2" name="Tytuł 1">
             <a:extLst>
               <a:ext uri="{FF2B5EF4-FFF2-40B4-BE49-F238E27FC236}">
-                <a16:creationId xmlns:a16="http://schemas.microsoft.com/office/drawing/2014/main" id="{D0B8A69A-FCE4-1153-712A-FAC99C76CCDF}"/>
-              </a:ext>
-            </a:extLst>
-          </p:cNvPr>
-          <p:cNvSpPr>
-            <a:spLocks noGrp="1"/>
-          </p:cNvSpPr>
-          <p:nvPr>
-            <p:ph type="ctrTitle"/>
+                <a16:creationId xmlns:a16="http://schemas.microsoft.com/office/drawing/2014/main" id="{77407CC0-3BB3-4563-A997-6BDBBB130FFE}"/>
+              </a:ext>
+            </a:extLst>
+          </p:cNvPr>
+          <p:cNvSpPr>
+            <a:spLocks noGrp="1"/>
+          </p:cNvSpPr>
+          <p:nvPr>
+            <p:ph type="title"/>
           </p:nvPr>
         </p:nvSpPr>
         <p:spPr/>
@@ -4975,7 +5950,7 @@
           <a:p>
             <a:r>
               <a:rPr lang="pl-PL" dirty="0"/>
-              <a:t>	TU CALE ZDJECIA I STATYSTYKA </a:t>
+              <a:t>Rozszerzenie modelu</a:t>
             </a:r>
             <a:endParaRPr lang="en-US" dirty="0"/>
           </a:p>
@@ -4983,47 +5958,206 @@
       </p:sp>
       <p:sp>
         <p:nvSpPr>
-          <p:cNvPr id="3" name="Podtytuł 2">
-            <a:extLst>
-              <a:ext uri="{FF2B5EF4-FFF2-40B4-BE49-F238E27FC236}">
-                <a16:creationId xmlns:a16="http://schemas.microsoft.com/office/drawing/2014/main" id="{53B25650-7C85-A4E5-2F5F-CB2D99D6E4C4}"/>
-              </a:ext>
-            </a:extLst>
-          </p:cNvPr>
-          <p:cNvSpPr>
-            <a:spLocks noGrp="1"/>
-          </p:cNvSpPr>
-          <p:nvPr>
-            <p:ph type="subTitle" idx="1"/>
-          </p:nvPr>
-        </p:nvSpPr>
-        <p:spPr/>
+          <p:cNvPr id="3" name="Symbol zastępczy zawartości 2">
+            <a:extLst>
+              <a:ext uri="{FF2B5EF4-FFF2-40B4-BE49-F238E27FC236}">
+                <a16:creationId xmlns:a16="http://schemas.microsoft.com/office/drawing/2014/main" id="{BA4F3297-7DD6-0EF4-82F1-773AB2F43F61}"/>
+              </a:ext>
+            </a:extLst>
+          </p:cNvPr>
+          <p:cNvSpPr>
+            <a:spLocks noGrp="1"/>
+          </p:cNvSpPr>
+          <p:nvPr>
+            <p:ph idx="1"/>
+          </p:nvPr>
+        </p:nvSpPr>
+        <p:spPr>
+          <a:xfrm>
+            <a:off x="838200" y="1825625"/>
+            <a:ext cx="10198768" cy="4351338"/>
+          </a:xfrm>
+        </p:spPr>
         <p:txBody>
           <a:bodyPr>
             <a:normAutofit/>
           </a:bodyPr>
           <a:lstStyle/>
           <a:p>
-            <a:r>
-              <a:rPr lang="pl-PL" sz="4800" dirty="0">
-                <a:highlight>
-                  <a:srgbClr val="FFFF00"/>
-                </a:highlight>
-              </a:rPr>
-              <a:t>DO ZROBIENIA</a:t>
-            </a:r>
-            <a:endParaRPr lang="en-US" sz="4800" dirty="0">
-              <a:highlight>
-                <a:srgbClr val="FFFF00"/>
-              </a:highlight>
-            </a:endParaRPr>
-          </a:p>
-        </p:txBody>
-      </p:sp>
+            <a:pPr>
+              <a:buFont typeface="Wingdings" panose="05000000000000000000" pitchFamily="2" charset="2"/>
+              <a:buChar char="§"/>
+            </a:pPr>
+            <a:r>
+              <a:rPr lang="pl-PL" sz="3600" dirty="0"/>
+              <a:t>Extended – zwiększamy sąsiedztwo o przekątne (do 8 z 4).</a:t>
+            </a:r>
+          </a:p>
+          <a:p>
+            <a:pPr>
+              <a:buFont typeface="Wingdings" panose="05000000000000000000" pitchFamily="2" charset="2"/>
+              <a:buChar char="§"/>
+            </a:pPr>
+            <a:r>
+              <a:rPr lang="pl-PL" sz="3600" dirty="0"/>
+              <a:t>Model toroidalny - </a:t>
+            </a:r>
+            <a:r>
+              <a:rPr lang="en-US" sz="3600" dirty="0" err="1"/>
+              <a:t>Zwijamy</a:t>
+            </a:r>
+            <a:r>
+              <a:rPr lang="en-US" sz="3600" dirty="0"/>
+              <a:t> </a:t>
+            </a:r>
+            <a:r>
+              <a:rPr lang="en-US" sz="3600" dirty="0" err="1"/>
+              <a:t>siatkę</a:t>
+            </a:r>
+            <a:r>
+              <a:rPr lang="en-US" sz="3600" dirty="0"/>
+              <a:t> w </a:t>
+            </a:r>
+            <a:r>
+              <a:rPr lang="en-US" sz="3600" dirty="0" err="1"/>
+              <a:t>kształt</a:t>
+            </a:r>
+            <a:r>
+              <a:rPr lang="en-US" sz="3600" dirty="0"/>
+              <a:t> </a:t>
+            </a:r>
+            <a:r>
+              <a:rPr lang="en-US" sz="3600" dirty="0" err="1"/>
+              <a:t>torusa</a:t>
+            </a:r>
+            <a:r>
+              <a:rPr lang="en-US" sz="3600" dirty="0"/>
+              <a:t> – </a:t>
+            </a:r>
+            <a:r>
+              <a:rPr lang="en-US" sz="3600" dirty="0" err="1"/>
+              <a:t>agenci</a:t>
+            </a:r>
+            <a:r>
+              <a:rPr lang="en-US" sz="3600" dirty="0"/>
+              <a:t> z </a:t>
+            </a:r>
+            <a:r>
+              <a:rPr lang="en-US" sz="3600" dirty="0" err="1"/>
+              <a:t>lewej</a:t>
+            </a:r>
+            <a:r>
+              <a:rPr lang="en-US" sz="3600" dirty="0"/>
+              <a:t> </a:t>
+            </a:r>
+            <a:r>
+              <a:rPr lang="en-US" sz="3600" dirty="0" err="1"/>
+              <a:t>krawędzi</a:t>
+            </a:r>
+            <a:r>
+              <a:rPr lang="en-US" sz="3600" dirty="0"/>
+              <a:t> </a:t>
+            </a:r>
+            <a:r>
+              <a:rPr lang="en-US" sz="3600" dirty="0" err="1"/>
+              <a:t>łączą</a:t>
+            </a:r>
+            <a:r>
+              <a:rPr lang="en-US" sz="3600" dirty="0"/>
+              <a:t> </a:t>
+            </a:r>
+            <a:r>
+              <a:rPr lang="en-US" sz="3600" dirty="0" err="1"/>
+              <a:t>się</a:t>
+            </a:r>
+            <a:r>
+              <a:rPr lang="en-US" sz="3600" dirty="0"/>
+              <a:t> </a:t>
+            </a:r>
+            <a:r>
+              <a:rPr lang="en-US" sz="3600" dirty="0" err="1"/>
+              <a:t>bezpośrednio</a:t>
+            </a:r>
+            <a:r>
+              <a:rPr lang="en-US" sz="3600" dirty="0"/>
+              <a:t> z </a:t>
+            </a:r>
+            <a:r>
+              <a:rPr lang="en-US" sz="3600" dirty="0" err="1"/>
+              <a:t>prawą</a:t>
+            </a:r>
+            <a:r>
+              <a:rPr lang="en-US" sz="3600" dirty="0"/>
+              <a:t>, </a:t>
+            </a:r>
+            <a:r>
+              <a:rPr lang="en-US" sz="3600" dirty="0" err="1"/>
+              <a:t>wyrównując</a:t>
+            </a:r>
+            <a:r>
+              <a:rPr lang="en-US" sz="3600" dirty="0"/>
+              <a:t> </a:t>
+            </a:r>
+            <a:r>
+              <a:rPr lang="en-US" sz="3600" dirty="0" err="1"/>
+              <a:t>szanse</a:t>
+            </a:r>
+            <a:r>
+              <a:rPr lang="en-US" sz="3600" dirty="0"/>
+              <a:t> </a:t>
+            </a:r>
+            <a:r>
+              <a:rPr lang="en-US" sz="3600" dirty="0" err="1"/>
+              <a:t>interakcj</a:t>
+            </a:r>
+            <a:r>
+              <a:rPr lang="pl-PL" sz="3600" dirty="0"/>
+              <a:t>i.</a:t>
+            </a:r>
+          </a:p>
+          <a:p>
+            <a:pPr>
+              <a:buFont typeface="Wingdings" panose="05000000000000000000" pitchFamily="2" charset="2"/>
+              <a:buChar char="§"/>
+            </a:pPr>
+            <a:endParaRPr lang="en-US" sz="3600" dirty="0"/>
+          </a:p>
+        </p:txBody>
+      </p:sp>
+      <p:pic>
+        <p:nvPicPr>
+          <p:cNvPr id="5" name="Obraz 4">
+            <a:extLst>
+              <a:ext uri="{FF2B5EF4-FFF2-40B4-BE49-F238E27FC236}">
+                <a16:creationId xmlns:a16="http://schemas.microsoft.com/office/drawing/2014/main" id="{B5D8E6B7-A676-19C9-FBC0-6F82629BCBDD}"/>
+              </a:ext>
+            </a:extLst>
+          </p:cNvPr>
+          <p:cNvPicPr>
+            <a:picLocks noChangeAspect="1"/>
+          </p:cNvPicPr>
+          <p:nvPr/>
+        </p:nvPicPr>
+        <p:blipFill>
+          <a:blip r:embed="rId2"/>
+          <a:stretch>
+            <a:fillRect/>
+          </a:stretch>
+        </p:blipFill>
+        <p:spPr>
+          <a:xfrm>
+            <a:off x="8549941" y="3962400"/>
+            <a:ext cx="3261175" cy="2735179"/>
+          </a:xfrm>
+          <a:prstGeom prst="rect">
+            <a:avLst/>
+          </a:prstGeom>
+        </p:spPr>
+      </p:pic>
     </p:spTree>
     <p:extLst>
       <p:ext uri="{BB962C8B-B14F-4D97-AF65-F5344CB8AC3E}">
-        <p14:creationId xmlns:p14="http://schemas.microsoft.com/office/powerpoint/2010/main" val="3546194582"/>
+        <p14:creationId xmlns:p14="http://schemas.microsoft.com/office/powerpoint/2010/main" val="1142525123"/>
       </p:ext>
     </p:extLst>
   </p:cSld>
@@ -5055,7 +6189,7 @@
           <p:cNvPr id="2" name="Tytuł 1">
             <a:extLst>
               <a:ext uri="{FF2B5EF4-FFF2-40B4-BE49-F238E27FC236}">
-                <a16:creationId xmlns:a16="http://schemas.microsoft.com/office/drawing/2014/main" id="{77407CC0-3BB3-4563-A997-6BDBBB130FFE}"/>
+                <a16:creationId xmlns:a16="http://schemas.microsoft.com/office/drawing/2014/main" id="{958507E3-A492-ADE9-9CC9-39CA0FE7FF78}"/>
               </a:ext>
             </a:extLst>
           </p:cNvPr>
@@ -5073,7 +6207,7 @@
           <a:p>
             <a:r>
               <a:rPr lang="pl-PL" dirty="0"/>
-              <a:t>WNIO</a:t>
+              <a:t>Rezultat rozszerzenia modelu</a:t>
             </a:r>
             <a:endParaRPr lang="en-US" dirty="0"/>
           </a:p>
@@ -5084,7 +6218,7 @@
           <p:cNvPr id="3" name="Symbol zastępczy zawartości 2">
             <a:extLst>
               <a:ext uri="{FF2B5EF4-FFF2-40B4-BE49-F238E27FC236}">
-                <a16:creationId xmlns:a16="http://schemas.microsoft.com/office/drawing/2014/main" id="{BA4F3297-7DD6-0EF4-82F1-773AB2F43F61}"/>
+                <a16:creationId xmlns:a16="http://schemas.microsoft.com/office/drawing/2014/main" id="{0A2EC9DE-B8DC-3284-A196-82B0FE9D5307}"/>
               </a:ext>
             </a:extLst>
           </p:cNvPr>
@@ -5100,14 +6234,22 @@
           <a:bodyPr/>
           <a:lstStyle/>
           <a:p>
-            <a:endParaRPr lang="en-US"/>
+            <a:pPr>
+              <a:buFont typeface="Wingdings" panose="05000000000000000000" pitchFamily="2" charset="2"/>
+              <a:buChar char="§"/>
+            </a:pPr>
+            <a:r>
+              <a:rPr lang="pl-PL" dirty="0"/>
+              <a:t>Szybsze ujednolicenie poprzez posiadanie większej ilości sąsiadów.</a:t>
+            </a:r>
+            <a:endParaRPr lang="en-US" dirty="0"/>
           </a:p>
         </p:txBody>
       </p:sp>
     </p:spTree>
     <p:extLst>
       <p:ext uri="{BB962C8B-B14F-4D97-AF65-F5344CB8AC3E}">
-        <p14:creationId xmlns:p14="http://schemas.microsoft.com/office/powerpoint/2010/main" val="1142525123"/>
+        <p14:creationId xmlns:p14="http://schemas.microsoft.com/office/powerpoint/2010/main" val="907463827"/>
       </p:ext>
     </p:extLst>
   </p:cSld>
@@ -5134,654 +6276,76 @@
           <a:chExt cx="0" cy="0"/>
         </a:xfrm>
       </p:grpSpPr>
-      <p:sp>
-        <p:nvSpPr>
-          <p:cNvPr id="2" name="Tytuł 1">
-            <a:extLst>
-              <a:ext uri="{FF2B5EF4-FFF2-40B4-BE49-F238E27FC236}">
-                <a16:creationId xmlns:a16="http://schemas.microsoft.com/office/drawing/2014/main" id="{CB6157CB-37E3-1BAD-1464-BA515DC4B543}"/>
-              </a:ext>
-            </a:extLst>
-          </p:cNvPr>
-          <p:cNvSpPr>
-            <a:spLocks noGrp="1"/>
-          </p:cNvSpPr>
-          <p:nvPr>
-            <p:ph type="title"/>
-          </p:nvPr>
-        </p:nvSpPr>
-        <p:spPr/>
-        <p:txBody>
-          <a:bodyPr/>
-          <a:lstStyle/>
-          <a:p>
-            <a:r>
-              <a:rPr lang="pl-PL" dirty="0"/>
-              <a:t>Wnioski końcowe</a:t>
-            </a:r>
-            <a:endParaRPr lang="en-US" dirty="0"/>
-          </a:p>
-        </p:txBody>
-      </p:sp>
-      <p:sp>
-        <p:nvSpPr>
-          <p:cNvPr id="3" name="Symbol zastępczy zawartości 2">
-            <a:extLst>
-              <a:ext uri="{FF2B5EF4-FFF2-40B4-BE49-F238E27FC236}">
-                <a16:creationId xmlns:a16="http://schemas.microsoft.com/office/drawing/2014/main" id="{DE8976C9-4BCF-B715-7CBA-4FBC45D36595}"/>
-              </a:ext>
-            </a:extLst>
-          </p:cNvPr>
-          <p:cNvSpPr>
-            <a:spLocks noGrp="1"/>
-          </p:cNvSpPr>
-          <p:nvPr>
-            <p:ph idx="1"/>
-          </p:nvPr>
-        </p:nvSpPr>
-        <p:spPr/>
-        <p:txBody>
-          <a:bodyPr>
-            <a:normAutofit fontScale="70000" lnSpcReduction="20000"/>
+      <p:pic>
+        <p:nvPicPr>
+          <p:cNvPr id="3" name="Obraz 2">
+            <a:extLst>
+              <a:ext uri="{FF2B5EF4-FFF2-40B4-BE49-F238E27FC236}">
+                <a16:creationId xmlns:a16="http://schemas.microsoft.com/office/drawing/2014/main" id="{18B7D6B0-EEBD-D815-15AE-8724C4FB03A0}"/>
+              </a:ext>
+            </a:extLst>
+          </p:cNvPr>
+          <p:cNvPicPr>
+            <a:picLocks noChangeAspect="1"/>
+          </p:cNvPicPr>
+          <p:nvPr/>
+        </p:nvPicPr>
+        <p:blipFill>
+          <a:blip r:embed="rId2"/>
+          <a:stretch>
+            <a:fillRect/>
+          </a:stretch>
+        </p:blipFill>
+        <p:spPr>
+          <a:xfrm>
+            <a:off x="633261" y="1465586"/>
+            <a:ext cx="10925477" cy="4552282"/>
+          </a:xfrm>
+          <a:prstGeom prst="rect">
+            <a:avLst/>
+          </a:prstGeom>
+        </p:spPr>
+      </p:pic>
+      <p:sp>
+        <p:nvSpPr>
+          <p:cNvPr id="4" name="pole tekstowe 3">
+            <a:extLst>
+              <a:ext uri="{FF2B5EF4-FFF2-40B4-BE49-F238E27FC236}">
+                <a16:creationId xmlns:a16="http://schemas.microsoft.com/office/drawing/2014/main" id="{097C5563-DBC3-3CBF-3A70-8EC67806C1BA}"/>
+              </a:ext>
+            </a:extLst>
+          </p:cNvPr>
+          <p:cNvSpPr txBox="1"/>
+          <p:nvPr/>
+        </p:nvSpPr>
+        <p:spPr>
+          <a:xfrm>
+            <a:off x="4748463" y="545431"/>
+            <a:ext cx="4812632" cy="584775"/>
+          </a:xfrm>
+          <a:prstGeom prst="rect">
+            <a:avLst/>
+          </a:prstGeom>
+          <a:noFill/>
+        </p:spPr>
+        <p:txBody>
+          <a:bodyPr wrap="square" rtlCol="0">
+            <a:spAutoFit/>
           </a:bodyPr>
           <a:lstStyle/>
           <a:p>
-            <a:pPr marL="0" indent="0">
-              <a:buNone/>
-            </a:pPr>
-            <a:r>
-              <a:rPr lang="en-US" dirty="0" err="1"/>
-              <a:t>Najważniejszy</a:t>
-            </a:r>
-            <a:r>
-              <a:rPr lang="en-US" dirty="0"/>
-              <a:t> </a:t>
-            </a:r>
-            <a:r>
-              <a:rPr lang="en-US" dirty="0" err="1"/>
-              <a:t>wniosek</a:t>
-            </a:r>
-            <a:r>
-              <a:rPr lang="en-US" dirty="0"/>
-              <a:t> </a:t>
-            </a:r>
-            <a:r>
-              <a:rPr lang="en-US" dirty="0" err="1"/>
-              <a:t>płynący</a:t>
-            </a:r>
-            <a:r>
-              <a:rPr lang="en-US" dirty="0"/>
-              <a:t> z </a:t>
-            </a:r>
-            <a:r>
-              <a:rPr lang="en-US" dirty="0" err="1"/>
-              <a:t>badań</a:t>
-            </a:r>
-            <a:r>
-              <a:rPr lang="en-US" dirty="0"/>
-              <a:t> </a:t>
-            </a:r>
-            <a:r>
-              <a:rPr lang="en-US" dirty="0" err="1"/>
-              <a:t>Axelroda</a:t>
-            </a:r>
-            <a:r>
-              <a:rPr lang="en-US" dirty="0"/>
-              <a:t> </a:t>
-            </a:r>
-            <a:r>
-              <a:rPr lang="en-US" dirty="0" err="1"/>
-              <a:t>wskazuje</a:t>
-            </a:r>
-            <a:r>
-              <a:rPr lang="en-US" dirty="0"/>
-              <a:t>, </a:t>
-            </a:r>
-            <a:r>
-              <a:rPr lang="en-US" dirty="0" err="1"/>
-              <a:t>że</a:t>
-            </a:r>
-            <a:r>
-              <a:rPr lang="en-US" dirty="0"/>
-              <a:t> </a:t>
-            </a:r>
-            <a:r>
-              <a:rPr lang="en-US" dirty="0" err="1"/>
-              <a:t>dążenie</a:t>
-            </a:r>
-            <a:r>
-              <a:rPr lang="en-US" dirty="0"/>
-              <a:t> do </a:t>
-            </a:r>
-            <a:r>
-              <a:rPr lang="en-US" dirty="0" err="1"/>
-              <a:t>lokalnego</a:t>
-            </a:r>
-            <a:r>
-              <a:rPr lang="en-US" dirty="0"/>
-              <a:t> </a:t>
-            </a:r>
-            <a:r>
-              <a:rPr lang="en-US" dirty="0" err="1"/>
-              <a:t>podobieństwa</a:t>
-            </a:r>
-            <a:r>
-              <a:rPr lang="pl-PL" dirty="0"/>
-              <a:t> </a:t>
-            </a:r>
-            <a:r>
-              <a:rPr lang="en-US"/>
-              <a:t>paradoksalnie</a:t>
-            </a:r>
-            <a:r>
-              <a:rPr lang="en-US" dirty="0"/>
-              <a:t> </a:t>
-            </a:r>
-            <a:r>
-              <a:rPr lang="en-US" dirty="0" err="1"/>
-              <a:t>uniemożliwia</a:t>
-            </a:r>
-            <a:r>
-              <a:rPr lang="en-US" dirty="0"/>
-              <a:t> </a:t>
-            </a:r>
-            <a:r>
-              <a:rPr lang="en-US" dirty="0" err="1"/>
-              <a:t>całkowite</a:t>
-            </a:r>
-            <a:r>
-              <a:rPr lang="en-US" dirty="0"/>
-              <a:t> </a:t>
-            </a:r>
-            <a:r>
-              <a:rPr lang="en-US" dirty="0" err="1"/>
-              <a:t>ujednolicenie</a:t>
-            </a:r>
-            <a:r>
-              <a:rPr lang="en-US" dirty="0"/>
-              <a:t> </a:t>
-            </a:r>
-            <a:r>
-              <a:rPr lang="en-US" dirty="0" err="1"/>
-              <a:t>całego</a:t>
-            </a:r>
-            <a:r>
-              <a:rPr lang="en-US" dirty="0"/>
-              <a:t> </a:t>
-            </a:r>
-            <a:r>
-              <a:rPr lang="en-US" dirty="0" err="1"/>
-              <a:t>społeczeństwa</a:t>
-            </a:r>
-            <a:r>
-              <a:rPr lang="en-US" dirty="0"/>
-              <a:t> </a:t>
-            </a:r>
-            <a:r>
-              <a:rPr lang="en-US" dirty="0" err="1"/>
-              <a:t>i</a:t>
-            </a:r>
-            <a:r>
-              <a:rPr lang="en-US" dirty="0"/>
-              <a:t> </a:t>
-            </a:r>
-            <a:r>
-              <a:rPr lang="en-US" dirty="0" err="1"/>
-              <a:t>cementuje</a:t>
-            </a:r>
-            <a:r>
-              <a:rPr lang="en-US" dirty="0"/>
-              <a:t>  </a:t>
-            </a:r>
-          </a:p>
-          <a:p>
-            <a:pPr marL="0" indent="0">
-              <a:buNone/>
-            </a:pPr>
-            <a:r>
-              <a:rPr lang="en-US" dirty="0"/>
-              <a:t>    </a:t>
-            </a:r>
-            <a:r>
-              <a:rPr lang="en-US" dirty="0" err="1"/>
-              <a:t>trwałe</a:t>
-            </a:r>
-            <a:r>
-              <a:rPr lang="en-US" dirty="0"/>
-              <a:t> </a:t>
-            </a:r>
-            <a:r>
-              <a:rPr lang="en-US" dirty="0" err="1"/>
-              <a:t>podziały</a:t>
-            </a:r>
-            <a:r>
-              <a:rPr lang="en-US" dirty="0"/>
-              <a:t> </a:t>
-            </a:r>
-            <a:r>
-              <a:rPr lang="en-US" dirty="0" err="1"/>
-              <a:t>kulturowe</a:t>
-            </a:r>
-            <a:r>
-              <a:rPr lang="en-US" dirty="0"/>
-              <a:t> </a:t>
-            </a:r>
-            <a:r>
-              <a:rPr lang="en-US" dirty="0" err="1"/>
-              <a:t>na</a:t>
-            </a:r>
-            <a:r>
-              <a:rPr lang="en-US" dirty="0"/>
-              <a:t> </a:t>
-            </a:r>
-            <a:r>
-              <a:rPr lang="en-US" dirty="0" err="1"/>
-              <a:t>poziomie</a:t>
-            </a:r>
-            <a:r>
-              <a:rPr lang="en-US" dirty="0"/>
-              <a:t> </a:t>
-            </a:r>
-            <a:r>
-              <a:rPr lang="en-US" dirty="0" err="1"/>
-              <a:t>globalnym</a:t>
-            </a:r>
-            <a:r>
-              <a:rPr lang="en-US" dirty="0"/>
-              <a:t> (</a:t>
-            </a:r>
-            <a:r>
-              <a:rPr lang="en-US" dirty="0" err="1"/>
-              <a:t>wyspy</a:t>
-            </a:r>
-            <a:r>
-              <a:rPr lang="en-US" dirty="0"/>
-              <a:t> </a:t>
-            </a:r>
-            <a:r>
-              <a:rPr lang="en-US" dirty="0" err="1"/>
-              <a:t>wspólne</a:t>
-            </a:r>
-            <a:r>
-              <a:rPr lang="en-US" dirty="0"/>
-              <a:t> </a:t>
-            </a:r>
-            <a:r>
-              <a:rPr lang="en-US" dirty="0" err="1"/>
-              <a:t>kulturowo</a:t>
-            </a:r>
-            <a:r>
-              <a:rPr lang="en-US" dirty="0"/>
-              <a:t>).</a:t>
-            </a:r>
-          </a:p>
-          <a:p>
-            <a:pPr marL="0" indent="0">
-              <a:buNone/>
-            </a:pPr>
-            <a:br>
-              <a:rPr lang="en-US" dirty="0"/>
-            </a:br>
-            <a:endParaRPr lang="en-US" dirty="0"/>
-          </a:p>
-          <a:p>
-            <a:pPr marL="0" indent="0">
-              <a:buNone/>
-            </a:pPr>
-            <a:r>
-              <a:rPr lang="en-US" dirty="0"/>
-              <a:t>    </a:t>
-            </a:r>
-            <a:r>
-              <a:rPr lang="en-US" dirty="0" err="1"/>
-              <a:t>Im</a:t>
-            </a:r>
-            <a:r>
-              <a:rPr lang="en-US" dirty="0"/>
-              <a:t> </a:t>
-            </a:r>
-            <a:r>
-              <a:rPr lang="en-US" dirty="0" err="1"/>
-              <a:t>więcej</a:t>
-            </a:r>
-            <a:r>
-              <a:rPr lang="en-US" dirty="0"/>
-              <a:t> </a:t>
-            </a:r>
-            <a:r>
-              <a:rPr lang="en-US" dirty="0" err="1"/>
-              <a:t>cech</a:t>
-            </a:r>
-            <a:r>
-              <a:rPr lang="en-US" dirty="0"/>
-              <a:t> </a:t>
-            </a:r>
-            <a:r>
-              <a:rPr lang="en-US" dirty="0" err="1"/>
-              <a:t>opisuje</a:t>
-            </a:r>
-            <a:r>
-              <a:rPr lang="en-US" dirty="0"/>
-              <a:t> </a:t>
-            </a:r>
-            <a:r>
-              <a:rPr lang="en-US" dirty="0" err="1"/>
-              <a:t>kulturę</a:t>
-            </a:r>
-            <a:r>
-              <a:rPr lang="en-US" dirty="0"/>
-              <a:t>, </a:t>
-            </a:r>
-            <a:r>
-              <a:rPr lang="en-US" dirty="0" err="1"/>
-              <a:t>tym</a:t>
-            </a:r>
-            <a:r>
-              <a:rPr lang="en-US" dirty="0"/>
-              <a:t> </a:t>
-            </a:r>
-            <a:r>
-              <a:rPr lang="en-US" dirty="0" err="1"/>
-              <a:t>mniej</a:t>
-            </a:r>
-            <a:r>
-              <a:rPr lang="en-US" dirty="0"/>
-              <a:t> </a:t>
-            </a:r>
-            <a:r>
-              <a:rPr lang="en-US" dirty="0" err="1"/>
-              <a:t>stabilnych</a:t>
-            </a:r>
-            <a:r>
-              <a:rPr lang="en-US" dirty="0"/>
-              <a:t> </a:t>
-            </a:r>
-            <a:r>
-              <a:rPr lang="en-US" dirty="0" err="1"/>
-              <a:t>regionów</a:t>
-            </a:r>
-            <a:r>
-              <a:rPr lang="en-US" dirty="0"/>
-              <a:t> </a:t>
-            </a:r>
-            <a:r>
-              <a:rPr lang="en-US" dirty="0" err="1"/>
-              <a:t>kulturowych</a:t>
-            </a:r>
-            <a:r>
-              <a:rPr lang="en-US" dirty="0"/>
-              <a:t> </a:t>
-            </a:r>
-            <a:r>
-              <a:rPr lang="en-US" dirty="0" err="1"/>
-              <a:t>pozostaje</a:t>
-            </a:r>
-            <a:r>
-              <a:rPr lang="en-US" dirty="0"/>
-              <a:t> </a:t>
-            </a:r>
-            <a:r>
-              <a:rPr lang="en-US" dirty="0" err="1"/>
-              <a:t>na</a:t>
-            </a:r>
-            <a:r>
-              <a:rPr lang="en-US" dirty="0"/>
-              <a:t> </a:t>
-            </a:r>
-            <a:r>
-              <a:rPr lang="en-US" dirty="0" err="1"/>
-              <a:t>końcu</a:t>
-            </a:r>
-            <a:r>
-              <a:rPr lang="en-US" dirty="0"/>
-              <a:t> </a:t>
-            </a:r>
-          </a:p>
-          <a:p>
-            <a:pPr marL="0" indent="0">
-              <a:buNone/>
-            </a:pPr>
-            <a:r>
-              <a:rPr lang="en-US" dirty="0"/>
-              <a:t>    (</a:t>
-            </a:r>
-            <a:r>
-              <a:rPr lang="en-US" dirty="0" err="1"/>
-              <a:t>sprzeczne</a:t>
-            </a:r>
-            <a:r>
-              <a:rPr lang="en-US" dirty="0"/>
-              <a:t> z </a:t>
-            </a:r>
-            <a:r>
-              <a:rPr lang="en-US" dirty="0" err="1"/>
-              <a:t>intuicją</a:t>
-            </a:r>
-            <a:r>
-              <a:rPr lang="en-US" dirty="0"/>
-              <a:t>). </a:t>
-            </a:r>
-            <a:r>
-              <a:rPr lang="en-US" dirty="0" err="1"/>
-              <a:t>Dzieje</a:t>
-            </a:r>
-            <a:r>
-              <a:rPr lang="en-US" dirty="0"/>
-              <a:t> </a:t>
-            </a:r>
-            <a:r>
-              <a:rPr lang="en-US" dirty="0" err="1"/>
-              <a:t>się</a:t>
-            </a:r>
-            <a:r>
-              <a:rPr lang="en-US" dirty="0"/>
-              <a:t> </a:t>
-            </a:r>
-            <a:r>
-              <a:rPr lang="en-US" dirty="0" err="1"/>
-              <a:t>tak</a:t>
-            </a:r>
-            <a:r>
-              <a:rPr lang="en-US" dirty="0"/>
-              <a:t>, </a:t>
-            </a:r>
-            <a:r>
-              <a:rPr lang="en-US" dirty="0" err="1"/>
-              <a:t>ponieważ</a:t>
-            </a:r>
-            <a:r>
-              <a:rPr lang="en-US" dirty="0"/>
-              <a:t> </a:t>
-            </a:r>
-            <a:r>
-              <a:rPr lang="en-US" dirty="0" err="1"/>
-              <a:t>większa</a:t>
-            </a:r>
-            <a:r>
-              <a:rPr lang="en-US" dirty="0"/>
-              <a:t> </a:t>
-            </a:r>
-            <a:r>
-              <a:rPr lang="en-US" dirty="0" err="1"/>
-              <a:t>liczba</a:t>
-            </a:r>
-            <a:r>
-              <a:rPr lang="en-US" dirty="0"/>
-              <a:t> </a:t>
-            </a:r>
-            <a:r>
-              <a:rPr lang="en-US" dirty="0" err="1"/>
-              <a:t>cech</a:t>
-            </a:r>
-            <a:r>
-              <a:rPr lang="en-US" dirty="0"/>
-              <a:t> </a:t>
-            </a:r>
-            <a:r>
-              <a:rPr lang="en-US" dirty="0" err="1"/>
-              <a:t>statystycznie</a:t>
-            </a:r>
-            <a:endParaRPr lang="en-US" dirty="0"/>
-          </a:p>
-          <a:p>
-            <a:pPr marL="0" indent="0">
-              <a:buNone/>
-            </a:pPr>
-            <a:r>
-              <a:rPr lang="en-US" dirty="0"/>
-              <a:t>     </a:t>
-            </a:r>
-            <a:r>
-              <a:rPr lang="en-US" dirty="0" err="1"/>
-              <a:t>zwiększa</a:t>
-            </a:r>
-            <a:r>
-              <a:rPr lang="en-US" dirty="0"/>
-              <a:t> </a:t>
-            </a:r>
-            <a:r>
-              <a:rPr lang="en-US" dirty="0" err="1"/>
-              <a:t>szansę</a:t>
-            </a:r>
-            <a:r>
-              <a:rPr lang="en-US" dirty="0"/>
-              <a:t> </a:t>
-            </a:r>
-            <a:r>
-              <a:rPr lang="en-US" dirty="0" err="1"/>
-              <a:t>posiadania</a:t>
-            </a:r>
-            <a:r>
-              <a:rPr lang="en-US" dirty="0"/>
-              <a:t> </a:t>
-            </a:r>
-            <a:r>
-              <a:rPr lang="en-US" dirty="0" err="1"/>
-              <a:t>jednego</a:t>
-            </a:r>
-            <a:r>
-              <a:rPr lang="en-US" dirty="0"/>
-              <a:t> </a:t>
-            </a:r>
-            <a:r>
-              <a:rPr lang="en-US" dirty="0" err="1"/>
-              <a:t>wspólnego</a:t>
-            </a:r>
-            <a:r>
-              <a:rPr lang="en-US" dirty="0"/>
-              <a:t> </a:t>
-            </a:r>
-            <a:r>
-              <a:rPr lang="en-US" dirty="0" err="1"/>
-              <a:t>elementu</a:t>
-            </a:r>
-            <a:r>
-              <a:rPr lang="en-US" dirty="0"/>
-              <a:t>, </a:t>
-            </a:r>
-            <a:r>
-              <a:rPr lang="en-US" dirty="0" err="1"/>
-              <a:t>czyli</a:t>
-            </a:r>
-            <a:r>
-              <a:rPr lang="en-US" dirty="0"/>
-              <a:t> </a:t>
-            </a:r>
-            <a:r>
-              <a:rPr lang="en-US" dirty="0" err="1"/>
-              <a:t>umożliwia</a:t>
-            </a:r>
-            <a:r>
-              <a:rPr lang="en-US" dirty="0"/>
-              <a:t> </a:t>
-            </a:r>
-            <a:r>
-              <a:rPr lang="en-US" dirty="0" err="1"/>
-              <a:t>interakcje</a:t>
-            </a:r>
-            <a:endParaRPr lang="en-US" dirty="0"/>
-          </a:p>
-          <a:p>
-            <a:pPr marL="0" indent="0">
-              <a:buNone/>
-            </a:pPr>
-            <a:r>
-              <a:rPr lang="en-US" dirty="0"/>
-              <a:t>      </a:t>
-            </a:r>
-            <a:r>
-              <a:rPr lang="en-US" dirty="0" err="1"/>
-              <a:t>i</a:t>
-            </a:r>
-            <a:r>
-              <a:rPr lang="en-US" dirty="0"/>
-              <a:t> </a:t>
-            </a:r>
-            <a:r>
-              <a:rPr lang="en-US" dirty="0" err="1"/>
-              <a:t>dalsze</a:t>
-            </a:r>
-            <a:r>
-              <a:rPr lang="en-US" dirty="0"/>
-              <a:t> </a:t>
-            </a:r>
-            <a:r>
-              <a:rPr lang="en-US" dirty="0" err="1"/>
-              <a:t>zwiększanie</a:t>
-            </a:r>
-            <a:r>
-              <a:rPr lang="en-US" dirty="0"/>
-              <a:t> </a:t>
-            </a:r>
-            <a:r>
-              <a:rPr lang="en-US" dirty="0" err="1"/>
-              <a:t>liczby</a:t>
-            </a:r>
-            <a:r>
-              <a:rPr lang="en-US" dirty="0"/>
-              <a:t> </a:t>
-            </a:r>
-            <a:r>
-              <a:rPr lang="en-US" dirty="0" err="1"/>
-              <a:t>wspólnych</a:t>
-            </a:r>
-            <a:r>
-              <a:rPr lang="en-US" dirty="0"/>
-              <a:t> </a:t>
-            </a:r>
-            <a:r>
-              <a:rPr lang="en-US" dirty="0" err="1"/>
-              <a:t>cech</a:t>
-            </a:r>
-            <a:r>
-              <a:rPr lang="en-US" dirty="0"/>
-              <a:t>.</a:t>
-            </a:r>
-          </a:p>
-          <a:p>
-            <a:pPr marL="0" indent="0">
-              <a:buNone/>
-            </a:pPr>
-            <a:r>
-              <a:rPr lang="en-US" dirty="0"/>
-              <a:t>    </a:t>
-            </a:r>
-          </a:p>
-          <a:p>
-            <a:br>
-              <a:rPr lang="en-US" dirty="0"/>
-            </a:br>
-            <a:endParaRPr lang="en-US" dirty="0"/>
-          </a:p>
-          <a:p>
-            <a:endParaRPr lang="en-US" dirty="0"/>
+            <a:r>
+              <a:rPr lang="pl-PL" sz="3200" dirty="0"/>
+              <a:t>Symulacja A</a:t>
+            </a:r>
+            <a:endParaRPr lang="en-US" sz="3200" dirty="0"/>
           </a:p>
         </p:txBody>
       </p:sp>
     </p:spTree>
     <p:extLst>
       <p:ext uri="{BB962C8B-B14F-4D97-AF65-F5344CB8AC3E}">
-        <p14:creationId xmlns:p14="http://schemas.microsoft.com/office/powerpoint/2010/main" val="3429367521"/>
+        <p14:creationId xmlns:p14="http://schemas.microsoft.com/office/powerpoint/2010/main" val="3206338473"/>
       </p:ext>
     </p:extLst>
   </p:cSld>

</xml_diff>